<commit_message>
Add proposal PPTX: The Cox Pradia Law Firm (May 29, 2026) — Dominate package
Updated Proposal.py to reflect Dominate + Master's Circle pricing;
regenerated 3-slide PPTX with correct $10,497 + $4,600 bundle.

Co-Authored-By: Claude Sonnet 4.6 <noreply@anthropic.com>
</commit_message>
<xml_diff>
--- a/cox-pradia/TheCoxPradiaLawFirm_May292026_Proposal.pptx
+++ b/cox-pradia/TheCoxPradiaLawFirm_May292026_Proposal.pptx
@@ -4629,7 +4629,7 @@
             <a:avLst/>
           </a:prstGeom>
           <a:solidFill>
-            <a:srgbClr val="2C1010"/>
+            <a:srgbClr val="0C2818"/>
           </a:solidFill>
           <a:ln>
             <a:solidFill>
@@ -4674,7 +4674,7 @@
             <a:avLst/>
           </a:prstGeom>
           <a:solidFill>
-            <a:srgbClr val="C0392B"/>
+            <a:srgbClr val="16A34A"/>
           </a:solidFill>
           <a:ln>
             <a:solidFill>
@@ -4732,7 +4732,7 @@
                 </a:solidFill>
                 <a:latin typeface="Calibri"/>
               </a:rPr>
-              <a:t>X</a:t>
+              <a:t>+</a:t>
             </a:r>
           </a:p>
         </p:txBody>
@@ -4761,11 +4761,11 @@
             <a:r>
               <a:rPr sz="1000" b="0" i="0">
                 <a:solidFill>
-                  <a:srgbClr val="F0BABA"/>
-                </a:solidFill>
-                <a:latin typeface="Calibri"/>
-              </a:rPr>
-              <a:t>No cost-per-case tracking — can't measure or optimize marketing ROI</a:t>
+                  <a:srgbClr val="86EFAC"/>
+                </a:solidFill>
+                <a:latin typeface="Calibri"/>
+              </a:rPr>
+              <a:t>10-person team with intake coordinators + case manager already in place</a:t>
             </a:r>
           </a:p>
         </p:txBody>
@@ -8815,7 +8815,7 @@
                 </a:solidFill>
                 <a:latin typeface="Calibri"/>
               </a:rPr>
-              <a:t>FULL SERVICE MARKETING — STARTER</a:t>
+              <a:t>FULL SERVICE MARKETING — DOMINATE</a:t>
             </a:r>
           </a:p>
         </p:txBody>
@@ -8848,7 +8848,7 @@
                 </a:solidFill>
                 <a:latin typeface="Calibri"/>
               </a:rPr>
-              <a:t>$4,847</a:t>
+              <a:t>$10,497</a:t>
             </a:r>
           </a:p>
         </p:txBody>
@@ -8914,7 +8914,7 @@
                 </a:solidFill>
                 <a:latin typeface="Calibri"/>
               </a:rPr>
-              <a:t>$5,697/mo</a:t>
+              <a:t>$12,497/mo</a:t>
             </a:r>
           </a:p>
         </p:txBody>
@@ -8992,7 +8992,7 @@
                 </a:solidFill>
                 <a:latin typeface="Calibri"/>
               </a:rPr>
-              <a:t>Google Ads · LSA · Meta · SEO · Website optimization</a:t>
+              <a:t>Google Ads · LSA · Meta · Full SEO · Website · All PI terms</a:t>
             </a:r>
           </a:p>
         </p:txBody>
@@ -9115,7 +9115,7 @@
                 </a:solidFill>
                 <a:latin typeface="Calibri"/>
               </a:rPr>
-              <a:t>ELITE COACH PLUS</a:t>
+              <a:t>MASTER'S CIRCLE</a:t>
             </a:r>
           </a:p>
         </p:txBody>
@@ -9148,7 +9148,7 @@
                 </a:solidFill>
                 <a:latin typeface="Calibri"/>
               </a:rPr>
-              <a:t>$3,200</a:t>
+              <a:t>$4,600</a:t>
             </a:r>
           </a:p>
         </p:txBody>
@@ -9214,7 +9214,7 @@
                 </a:solidFill>
                 <a:latin typeface="Calibri"/>
               </a:rPr>
-              <a:t>$3,497/mo</a:t>
+              <a:t>$4,997/mo</a:t>
             </a:r>
           </a:p>
         </p:txBody>
@@ -9292,7 +9292,7 @@
                 </a:solidFill>
                 <a:latin typeface="Calibri"/>
               </a:rPr>
-              <a:t>Weekly coaching · Masterminds · Workshops · 1:1 strategy</a:t>
+              <a:t>Weekly coaching · PI masterminds · Workshops · Strategy sessions</a:t>
             </a:r>
           </a:p>
         </p:txBody>
@@ -9403,7 +9403,7 @@
                 </a:solidFill>
                 <a:latin typeface="Calibri"/>
               </a:rPr>
-              <a:t>$8,047 / mo</a:t>
+              <a:t>$15,097 / mo</a:t>
             </a:r>
           </a:p>
         </p:txBody>
@@ -9436,7 +9436,7 @@
                 </a:solidFill>
                 <a:latin typeface="Calibri"/>
               </a:rPr>
-              <a:t>Save $1,147/mo by bundling</a:t>
+              <a:t>Save $2,397/mo by bundling</a:t>
             </a:r>
           </a:p>
         </p:txBody>
@@ -9514,7 +9514,7 @@
                 </a:solidFill>
                 <a:latin typeface="Calibri"/>
               </a:rPr>
-              <a:t>+ Recommended ad spend: $13,200–$22,000/mo paid directly to Google/Meta</a:t>
+              <a:t>+ Recommended ad spend: $20,000–$60,000/mo paid directly to Google/Meta</a:t>
             </a:r>
           </a:p>
         </p:txBody>
@@ -9658,7 +9658,7 @@
                 </a:solidFill>
                 <a:latin typeface="Calibri"/>
               </a:rPr>
-              <a:t>$50,000</a:t>
+              <a:t>$50,000 (est.)</a:t>
             </a:r>
           </a:p>
         </p:txBody>
@@ -9736,7 +9736,7 @@
                 </a:solidFill>
                 <a:latin typeface="Calibri"/>
               </a:rPr>
-              <a:t>Conservative  (3 cases/mo):</a:t>
+              <a:t>Conservative  (6 cases/mo):</a:t>
             </a:r>
           </a:p>
         </p:txBody>
@@ -9769,7 +9769,7 @@
                 </a:solidFill>
                 <a:latin typeface="Calibri"/>
               </a:rPr>
-              <a:t>$150,000 revenue · 11× ROAS</a:t>
+              <a:t>$300,000 revenue · 15× ROAS</a:t>
             </a:r>
           </a:p>
         </p:txBody>
@@ -9802,7 +9802,7 @@
                 </a:solidFill>
                 <a:latin typeface="Calibri"/>
               </a:rPr>
-              <a:t>Aggressive  (7 cases/mo):</a:t>
+              <a:t>Aggressive  (20 cases/mo):</a:t>
             </a:r>
           </a:p>
         </p:txBody>
@@ -9835,7 +9835,7 @@
                 </a:solidFill>
                 <a:latin typeface="Calibri"/>
               </a:rPr>
-              <a:t>$350,000 revenue · 16× ROAS</a:t>
+              <a:t>$1,000,000 revenue · 17× ROAS</a:t>
             </a:r>
           </a:p>
         </p:txBody>

</xml_diff>

<commit_message>
Add proposal PPTX: The Cox Pradia Law Firm (May 29, 2026) — Growth package
3-slide proposal: urgency 8/10, Growth ($7,397/mo) + Master's Circle ($4,600/mo),
total $11,997/mo, ad spend $19,500-$50,000/mo, ROI 15x-17x.

Co-Authored-By: Claude Sonnet 4.6 <noreply@anthropic.com>
</commit_message>
<xml_diff>
--- a/cox-pradia/TheCoxPradiaLawFirm_May292026_Proposal.pptx
+++ b/cox-pradia/TheCoxPradiaLawFirm_May292026_Proposal.pptx
@@ -3163,7 +3163,7 @@
                 </a:solidFill>
                 <a:latin typeface="Calibri"/>
               </a:rPr>
-              <a:t>LAW FIRM GROWTH AUDIT  ·  THE COX PRADIA LAW FIRM</a:t>
+              <a:t>LAW FIRM GROWTH AUDIT  -  THE COX PRADIA LAW FIRM</a:t>
             </a:r>
           </a:p>
         </p:txBody>
@@ -3541,7 +3541,7 @@
                 </a:solidFill>
                 <a:latin typeface="Calibri"/>
               </a:rPr>
-              <a:t>No ads observed</a:t>
+              <a:t>No ads — invisible</a:t>
             </a:r>
           </a:p>
         </p:txBody>
@@ -3697,7 +3697,7 @@
                 </a:solidFill>
                 <a:latin typeface="Calibri"/>
               </a:rPr>
-              <a:t>IN PROGRESS</a:t>
+              <a:t>AMBER</a:t>
             </a:r>
           </a:p>
         </p:txBody>
@@ -3730,7 +3730,7 @@
                 </a:solidFill>
                 <a:latin typeface="Calibri"/>
               </a:rPr>
-              <a:t>Footer-only form</a:t>
+              <a:t>Footer form only</a:t>
             </a:r>
           </a:p>
         </p:txBody>
@@ -3886,7 +3886,7 @@
                 </a:solidFill>
                 <a:latin typeface="Calibri"/>
               </a:rPr>
-              <a:t>IN PROGRESS</a:t>
+              <a:t>AMBER</a:t>
             </a:r>
           </a:p>
         </p:txBody>
@@ -3919,7 +3919,7 @@
                 </a:solidFill>
                 <a:latin typeface="Calibri"/>
               </a:rPr>
-              <a:t>No mgmt layer</a:t>
+              <a:t>10-person team built</a:t>
             </a:r>
           </a:p>
         </p:txBody>
@@ -4108,7 +4108,7 @@
                 </a:solidFill>
                 <a:latin typeface="Calibri"/>
               </a:rPr>
-              <a:t>No revenue tracking</a:t>
+              <a:t>No revenue data</a:t>
             </a:r>
           </a:p>
         </p:txBody>
@@ -4297,7 +4297,7 @@
                 </a:solidFill>
                 <a:latin typeface="Calibri"/>
               </a:rPr>
-              <a:t>Not running ads while competitors spend $250K–$900K+/yr on Google</a:t>
+              <a:t>Invisible on paid search — Zehl spends $913K+/yr on Google Ads alone</a:t>
             </a:r>
           </a:p>
         </p:txBody>
@@ -4453,7 +4453,7 @@
                 </a:solidFill>
                 <a:latin typeface="Calibri"/>
               </a:rPr>
-              <a:t>Two addresses + 3 phone numbers across directories suppress 3-pack rank</a:t>
+              <a:t>2 addresses + 3 phone numbers hurt Google 3-pack ranking signals</a:t>
             </a:r>
           </a:p>
         </p:txBody>
@@ -4609,7 +4609,7 @@
                 </a:solidFill>
                 <a:latin typeface="Calibri"/>
               </a:rPr>
-              <a:t>No live chat + footer-only form — after-hours leads leave unconverted</a:t>
+              <a:t>Footer-only form means after-hours visitors leave with no intake path</a:t>
             </a:r>
           </a:p>
         </p:txBody>
@@ -4765,7 +4765,7 @@
                 </a:solidFill>
                 <a:latin typeface="Calibri"/>
               </a:rPr>
-              <a:t>10-person team with intake coordinators + case manager already in place</a:t>
+              <a:t>10-person team with intake coordinators &amp; case manager already in place</a:t>
             </a:r>
           </a:p>
         </p:txBody>
@@ -4966,7 +4966,7 @@
                 </a:solidFill>
                 <a:latin typeface="Calibri"/>
               </a:rPr>
-              <a:t>Stage 4: Small Business Manager  →  Goal: Stage 6, Law Firm Owner</a:t>
+              <a:t>Stage 4: Small Business Manager  -&gt;  Goal: Stage 6, Law Firm Owner</a:t>
             </a:r>
           </a:p>
         </p:txBody>
@@ -5110,7 +5110,7 @@
                 </a:solidFill>
                 <a:latin typeface="Calibri"/>
               </a:rPr>
-              <a:t>1,262 reviews · 5.0★</a:t>
+              <a:t>1,262 reviews 5.0</a:t>
             </a:r>
           </a:p>
         </p:txBody>
@@ -5143,7 +5143,7 @@
                 </a:solidFill>
                 <a:latin typeface="Calibri"/>
               </a:rPr>
-              <a:t>Google Screened</a:t>
+              <a:t>Google Screened, $913K/yr ads</a:t>
             </a:r>
           </a:p>
         </p:txBody>
@@ -5254,7 +5254,7 @@
                 </a:solidFill>
                 <a:latin typeface="Calibri"/>
               </a:rPr>
-              <a:t>502 reviews · 4.9★</a:t>
+              <a:t>502 reviews 4.9</a:t>
             </a:r>
           </a:p>
         </p:txBody>
@@ -5287,7 +5287,7 @@
                 </a:solidFill>
                 <a:latin typeface="Calibri"/>
               </a:rPr>
-              <a:t>Google Screened</a:t>
+              <a:t>Google Screened, $384K/yr ads</a:t>
             </a:r>
           </a:p>
         </p:txBody>
@@ -5365,7 +5365,7 @@
                 </a:solidFill>
                 <a:latin typeface="Calibri"/>
               </a:rPr>
-              <a:t>Terry Bryant Law</a:t>
+              <a:t>Terry Bryant Injury Law</a:t>
             </a:r>
           </a:p>
         </p:txBody>
@@ -5398,7 +5398,7 @@
                 </a:solidFill>
                 <a:latin typeface="Calibri"/>
               </a:rPr>
-              <a:t>100 reviews · 4.6★</a:t>
+              <a:t>100 reviews 4.6</a:t>
             </a:r>
           </a:p>
         </p:txBody>
@@ -5431,7 +5431,7 @@
                 </a:solidFill>
                 <a:latin typeface="Calibri"/>
               </a:rPr>
-              <a:t>$272K/yr ads</a:t>
+              <a:t>$272K/yr ads, board certified</a:t>
             </a:r>
           </a:p>
         </p:txBody>
@@ -5587,7 +5587,7 @@
                 </a:solidFill>
                 <a:latin typeface="Calibri"/>
               </a:rPr>
-              <a:t>51 reviews · 4.4★</a:t>
+              <a:t>51 reviews 4.4</a:t>
             </a:r>
           </a:p>
         </p:txBody>
@@ -5620,7 +5620,7 @@
                 </a:solidFill>
                 <a:latin typeface="Calibri"/>
               </a:rPr>
-              <a:t>← You are here</a:t>
+              <a:t>You are here</a:t>
             </a:r>
           </a:p>
         </p:txBody>
@@ -5722,7 +5722,7 @@
                 </a:solidFill>
                 <a:latin typeface="Calibri"/>
               </a:rPr>
-              <a:t>CONFIDENTIAL  ·  Prepared by Nick Holderman | SMB Team</a:t>
+              <a:t>CONFIDENTIAL  -  Prepared by Nick Holderman | SMB Team</a:t>
             </a:r>
           </a:p>
         </p:txBody>
@@ -5851,7 +5851,7 @@
                 </a:solidFill>
                 <a:latin typeface="Calibri"/>
               </a:rPr>
-              <a:t>LAW FIRM GROWTH AUDIT  ·  THE COX PRADIA LAW FIRM</a:t>
+              <a:t>LAW FIRM GROWTH AUDIT  -  THE COX PRADIA LAW FIRM</a:t>
             </a:r>
           </a:p>
         </p:txBody>
@@ -5884,7 +5884,7 @@
                 </a:solidFill>
                 <a:latin typeface="Calibri"/>
               </a:rPr>
-              <a:t>Your Growth Plan: 3 Priorities to Build Your PI Pipeline</a:t>
+              <a:t>Your Growth Plan: 3 Priorities for The Cox Pradia Law Firm</a:t>
             </a:r>
           </a:p>
         </p:txBody>
@@ -6040,7 +6040,7 @@
                 </a:solidFill>
                 <a:latin typeface="Calibri"/>
               </a:rPr>
-              <a:t>Lead Gen, Intake, Team, and Profit must work together as one system. When all four pillars fire, Cox and Pradia can focus on the high-value cases that define their practice — while the firm handles the rest.</a:t>
+              <a:t>Lead Generation. Intake. Self-Managing Team. Profit Plan. All four must work together. Cox Pradia has the team and track record. When the marketing engine is added, the firm grows without the partners personally driving every case.</a:t>
             </a:r>
           </a:p>
         </p:txBody>
@@ -6118,7 +6118,7 @@
                 </a:solidFill>
                 <a:latin typeface="Calibri"/>
               </a:rPr>
-              <a:t>Referrals → Reliable Case Engine</a:t>
+              <a:t>40 yrs of reputation -&gt; predictable case flow</a:t>
             </a:r>
           </a:p>
         </p:txBody>
@@ -6151,7 +6151,7 @@
                 </a:solidFill>
                 <a:latin typeface="Calibri"/>
               </a:rPr>
-              <a:t>Focus on the cases that matter most</a:t>
+              <a:t>Focus on cases -- not finding them</a:t>
             </a:r>
           </a:p>
         </p:txBody>
@@ -6418,7 +6418,7 @@
                 </a:solidFill>
                 <a:latin typeface="Calibri"/>
               </a:rPr>
-              <a:t>Turn Google into your main PI pipeline</a:t>
+              <a:t>Turn Google into a client pipeline that runs itself</a:t>
             </a:r>
           </a:p>
         </p:txBody>
@@ -6541,7 +6541,7 @@
                 </a:solidFill>
                 <a:latin typeface="Calibri"/>
               </a:rPr>
-              <a:t>Launch LSA — pay per lead, not per click</a:t>
+              <a:t>Win the top LSA spot above every paid ad</a:t>
             </a:r>
           </a:p>
         </p:txBody>
@@ -6664,7 +6664,7 @@
                 </a:solidFill>
                 <a:latin typeface="Calibri"/>
               </a:rPr>
-              <a:t>Fix NAP: unify address + phone everywhere</a:t>
+              <a:t>Fix directory listings to reclaim 3-pack eligibility</a:t>
             </a:r>
           </a:p>
         </p:txBody>
@@ -6787,7 +6787,7 @@
                 </a:solidFill>
                 <a:latin typeface="Calibri"/>
               </a:rPr>
-              <a:t>Build suburb pages: Katy, Sugar Land, Woodlands</a:t>
+              <a:t>Build review velocity to outpace Houston competitors</a:t>
             </a:r>
           </a:p>
         </p:txBody>
@@ -6910,7 +6910,7 @@
                 </a:solidFill>
                 <a:latin typeface="Calibri"/>
               </a:rPr>
-              <a:t>Target Houston's Spanish-speaking community</a:t>
+              <a:t>Add suburb pages for Katy, Sugar Land, Woodlands</a:t>
             </a:r>
           </a:p>
         </p:txBody>
@@ -7177,7 +7177,7 @@
                 </a:solidFill>
                 <a:latin typeface="Calibri"/>
               </a:rPr>
-              <a:t>Move contact form above the fold today</a:t>
+              <a:t>Add above-fold form to capture leads before they leave</a:t>
             </a:r>
           </a:p>
         </p:txBody>
@@ -7300,7 +7300,7 @@
                 </a:solidFill>
                 <a:latin typeface="Calibri"/>
               </a:rPr>
-              <a:t>Add live chat — never miss an after-hours case</a:t>
+              <a:t>Activate Avvo reviews to close the directory trust gap</a:t>
             </a:r>
           </a:p>
         </p:txBody>
@@ -7423,7 +7423,7 @@
                 </a:solidFill>
                 <a:latin typeface="Calibri"/>
               </a:rPr>
-              <a:t>Activate Avvo reviews for Jonathan Cox</a:t>
+              <a:t>Set response standards -- first to respond wins cases</a:t>
             </a:r>
           </a:p>
         </p:txBody>
@@ -7546,7 +7546,7 @@
                 </a:solidFill>
                 <a:latin typeface="Calibri"/>
               </a:rPr>
-              <a:t>Track speed-to-response and intake close rate</a:t>
+              <a:t>Launch post-case Google review collection system</a:t>
             </a:r>
           </a:p>
         </p:txBody>
@@ -7669,7 +7669,7 @@
                 </a:solidFill>
                 <a:latin typeface="Calibri"/>
               </a:rPr>
-              <a:t>Launch review velocity — 10+ new per month</a:t>
+              <a:t>Track close rate and case value by lead source</a:t>
             </a:r>
           </a:p>
         </p:txBody>
@@ -7936,7 +7936,7 @@
                 </a:solidFill>
                 <a:latin typeface="Calibri"/>
               </a:rPr>
-              <a:t>Define team KPIs — run without partner input</a:t>
+              <a:t>Define KPIs so the team runs without daily oversight</a:t>
             </a:r>
           </a:p>
         </p:txBody>
@@ -8059,7 +8059,7 @@
                 </a:solidFill>
                 <a:latin typeface="Calibri"/>
               </a:rPr>
-              <a:t>Track cost per case by lead source from day 1</a:t>
+              <a:t>Document intake SLAs for consistent follow-up</a:t>
             </a:r>
           </a:p>
         </p:txBody>
@@ -8182,7 +8182,7 @@
                 </a:solidFill>
                 <a:latin typeface="Calibri"/>
               </a:rPr>
-              <a:t>Set monthly revenue and case volume targets</a:t>
+              <a:t>Build monthly profit dashboard -- know the margins</a:t>
             </a:r>
           </a:p>
         </p:txBody>
@@ -8305,7 +8305,7 @@
                 </a:solidFill>
                 <a:latin typeface="Calibri"/>
               </a:rPr>
-              <a:t>Build management layer between partners + staff</a:t>
+              <a:t>Track cost-per-case and double down on winners</a:t>
             </a:r>
           </a:p>
         </p:txBody>
@@ -8428,7 +8428,7 @@
                 </a:solidFill>
                 <a:latin typeface="Calibri"/>
               </a:rPr>
-              <a:t>Phase 2: add ops support when volume confirms</a:t>
+              <a:t>Master's Circle: peer coaching with $1M+ firm owners</a:t>
             </a:r>
           </a:p>
         </p:txBody>
@@ -8530,7 +8530,7 @@
                 </a:solidFill>
                 <a:latin typeface="Calibri"/>
               </a:rPr>
-              <a:t>CONFIDENTIAL  ·  Prepared by Nick Holderman | SMB Team</a:t>
+              <a:t>CONFIDENTIAL  -  Prepared by Nick Holderman | SMB Team</a:t>
             </a:r>
           </a:p>
         </p:txBody>
@@ -8659,7 +8659,7 @@
                 </a:solidFill>
                 <a:latin typeface="Calibri"/>
               </a:rPr>
-              <a:t>LAW FIRM GROWTH AUDIT  ·  THE COX PRADIA LAW FIRM</a:t>
+              <a:t>LAW FIRM GROWTH AUDIT  -  THE COX PRADIA LAW FIRM</a:t>
             </a:r>
           </a:p>
         </p:txBody>
@@ -8815,7 +8815,7 @@
                 </a:solidFill>
                 <a:latin typeface="Calibri"/>
               </a:rPr>
-              <a:t>FULL SERVICE MARKETING — DOMINATE</a:t>
+              <a:t>FULL SERVICE MARKETING -- GROWTH</a:t>
             </a:r>
           </a:p>
         </p:txBody>
@@ -8848,7 +8848,7 @@
                 </a:solidFill>
                 <a:latin typeface="Calibri"/>
               </a:rPr>
-              <a:t>$10,497</a:t>
+              <a:t>$7,397</a:t>
             </a:r>
           </a:p>
         </p:txBody>
@@ -8914,7 +8914,7 @@
                 </a:solidFill>
                 <a:latin typeface="Calibri"/>
               </a:rPr>
-              <a:t>$12,497/mo</a:t>
+              <a:t>$8,997/mo</a:t>
             </a:r>
           </a:p>
         </p:txBody>
@@ -8992,7 +8992,7 @@
                 </a:solidFill>
                 <a:latin typeface="Calibri"/>
               </a:rPr>
-              <a:t>Google Ads · LSA · Meta · Full SEO · Website · All PI terms</a:t>
+              <a:t>Google Ads, LSA, Meta Ads, SEO, Website Optimization</a:t>
             </a:r>
           </a:p>
         </p:txBody>
@@ -9292,7 +9292,7 @@
                 </a:solidFill>
                 <a:latin typeface="Calibri"/>
               </a:rPr>
-              <a:t>Weekly coaching · PI masterminds · Workshops · Strategy sessions</a:t>
+              <a:t>Weekly coaching, PI masterminds, Quarterly workshops</a:t>
             </a:r>
           </a:p>
         </p:txBody>
@@ -9403,7 +9403,7 @@
                 </a:solidFill>
                 <a:latin typeface="Calibri"/>
               </a:rPr>
-              <a:t>$15,097 / mo</a:t>
+              <a:t>$11,997 / mo</a:t>
             </a:r>
           </a:p>
         </p:txBody>
@@ -9436,7 +9436,7 @@
                 </a:solidFill>
                 <a:latin typeface="Calibri"/>
               </a:rPr>
-              <a:t>Save $2,397/mo by bundling</a:t>
+              <a:t>Save $1,997/mo by bundling</a:t>
             </a:r>
           </a:p>
         </p:txBody>
@@ -9514,7 +9514,7 @@
                 </a:solidFill>
                 <a:latin typeface="Calibri"/>
               </a:rPr>
-              <a:t>+ Recommended ad spend: $20,000–$60,000/mo paid directly to Google/Meta</a:t>
+              <a:t>+ Recommended ad spend: $19,500-$50,000/mo paid directly to Google/Meta</a:t>
             </a:r>
           </a:p>
         </p:txBody>
@@ -9658,7 +9658,7 @@
                 </a:solidFill>
                 <a:latin typeface="Calibri"/>
               </a:rPr>
-              <a:t>$50,000 (est.)</a:t>
+              <a:t>$50,000</a:t>
             </a:r>
           </a:p>
         </p:txBody>
@@ -9769,7 +9769,7 @@
                 </a:solidFill>
                 <a:latin typeface="Calibri"/>
               </a:rPr>
-              <a:t>$300,000 revenue · 15× ROAS</a:t>
+              <a:t>$300,000 revenue  15x ROAS</a:t>
             </a:r>
           </a:p>
         </p:txBody>
@@ -9802,7 +9802,7 @@
                 </a:solidFill>
                 <a:latin typeface="Calibri"/>
               </a:rPr>
-              <a:t>Aggressive  (20 cases/mo):</a:t>
+              <a:t>Aggressive  (17 cases/mo):</a:t>
             </a:r>
           </a:p>
         </p:txBody>
@@ -9835,7 +9835,7 @@
                 </a:solidFill>
                 <a:latin typeface="Calibri"/>
               </a:rPr>
-              <a:t>$1,000,000 revenue · 17× ROAS</a:t>
+              <a:t>$850,000 revenue  17x ROAS</a:t>
             </a:r>
           </a:p>
         </p:txBody>
@@ -9979,7 +9979,7 @@
                 </a:solidFill>
                 <a:latin typeface="Calibri"/>
               </a:rPr>
-              <a:t>Google Ads + LSA campaigns launched</a:t>
+              <a:t>Google Ads &amp; LSA campaigns launched</a:t>
             </a:r>
           </a:p>
         </p:txBody>
@@ -10090,7 +10090,7 @@
                 </a:solidFill>
                 <a:latin typeface="Calibri"/>
               </a:rPr>
-              <a:t>NAP corrected across all major directories</a:t>
+              <a:t>NAP corrections across all directories</a:t>
             </a:r>
           </a:p>
         </p:txBody>
@@ -10201,7 +10201,7 @@
                 </a:solidFill>
                 <a:latin typeface="Calibri"/>
               </a:rPr>
-              <a:t>Above-fold form + live chat on homepage</a:t>
+              <a:t>Above-fold form + Katy/Sugar Land pages live</a:t>
             </a:r>
           </a:p>
         </p:txBody>
@@ -10312,7 +10312,7 @@
                 </a:solidFill>
                 <a:latin typeface="Calibri"/>
               </a:rPr>
-              <a:t>Suburb landing pages live — Katy, Sugar Land</a:t>
+              <a:t>Google review request system activated</a:t>
             </a:r>
           </a:p>
         </p:txBody>
@@ -10423,7 +10423,7 @@
                 </a:solidFill>
                 <a:latin typeface="Calibri"/>
               </a:rPr>
-              <a:t>10+ new Google reviews; 3-pack momentum building</a:t>
+              <a:t>Coaching kickoff + case tracking live</a:t>
             </a:r>
           </a:p>
         </p:txBody>
@@ -10501,7 +10501,7 @@
                 </a:solidFill>
                 <a:latin typeface="Calibri"/>
               </a:rPr>
-              <a:t>"Forty years fighting for Houston families, and the system to match it — more cases, better clients, and the freedom to choose the work that matters."</a:t>
+              <a:t>"The cases are in this market. The team is already in place. The only thing missing is the system that turns this firm's reputation into revenue -- and that is exactly what we build."</a:t>
             </a:r>
           </a:p>
         </p:txBody>
@@ -10603,7 +10603,7 @@
                 </a:solidFill>
                 <a:latin typeface="Calibri"/>
               </a:rPr>
-              <a:t>CONFIDENTIAL  ·  Prepared by Nick Holderman | SMB Team</a:t>
+              <a:t>CONFIDENTIAL  -  Prepared by Nick Holderman | SMB Team</a:t>
             </a:r>
           </a:p>
         </p:txBody>

</xml_diff>

<commit_message>
Update Cox Pradia proposal: Full-Service Marketing Growth only + $2,200 setup fee
Removed Master's Circle package; proposal now shows Full-Service Marketing
Growth ($7,397/mo) as the single offering. Added $2,200 one-time setup fee
box on slide 3. Kept all competitor ad spend data and ROAS projections.
Updated Priority 3 and 90-day timeline to remove coaching references.

Co-Authored-By: Claude Sonnet 4.6 <noreply@anthropic.com>
</commit_message>
<xml_diff>
--- a/cox-pradia/TheCoxPradiaLawFirm_May292026_Proposal.pptx
+++ b/cox-pradia/TheCoxPradiaLawFirm_May292026_Proposal.pptx
@@ -8428,7 +8428,7 @@
                 </a:solidFill>
                 <a:latin typeface="Calibri"/>
               </a:rPr>
-              <a:t>Master's Circle: peer coaching with $1M+ firm owners</a:t>
+              <a:t>Build a referral engine to convert case wins into new clients</a:t>
             </a:r>
           </a:p>
         </p:txBody>
@@ -9057,7 +9057,7 @@
             <a:avLst/>
           </a:prstGeom>
           <a:solidFill>
-            <a:srgbClr val="6D28D9"/>
+            <a:srgbClr val="F5C400"/>
           </a:solidFill>
           <a:ln>
             <a:solidFill>
@@ -9111,11 +9111,11 @@
             <a:r>
               <a:rPr sz="800" b="1" i="0">
                 <a:solidFill>
-                  <a:srgbClr val="6D28D9"/>
+                  <a:srgbClr val="F5C400"/>
                 </a:solidFill>
                 <a:latin typeface="Calibri"/>
               </a:rPr>
-              <a:t>MASTER'S CIRCLE</a:t>
+              <a:t>ONE-TIME SETUP FEE</a:t>
             </a:r>
           </a:p>
         </p:txBody>
@@ -9128,7 +9128,7 @@
         </p:nvSpPr>
         <p:spPr>
           <a:xfrm>
-            <a:off x="475488" y="2414015"/>
+            <a:off x="475488" y="2395728"/>
             <a:ext cx="1828800" cy="438912"/>
           </a:xfrm>
           <a:prstGeom prst="rect">
@@ -9148,7 +9148,7 @@
                 </a:solidFill>
                 <a:latin typeface="Calibri"/>
               </a:rPr>
-              <a:t>$4,600</a:t>
+              <a:t>$2,200</a:t>
             </a:r>
           </a:p>
         </p:txBody>
@@ -9161,8 +9161,8 @@
         </p:nvSpPr>
         <p:spPr>
           <a:xfrm>
-            <a:off x="1865376" y="2523744"/>
-            <a:ext cx="420624" cy="256032"/>
+            <a:off x="1865376" y="2505456"/>
+            <a:ext cx="731520" cy="256032"/>
           </a:xfrm>
           <a:prstGeom prst="rect">
             <a:avLst/>
@@ -9181,7 +9181,7 @@
                 </a:solidFill>
                 <a:latin typeface="Calibri"/>
               </a:rPr>
-              <a:t>/mo</a:t>
+              <a:t>one-time</a:t>
             </a:r>
           </a:p>
         </p:txBody>
@@ -9194,8 +9194,8 @@
         </p:nvSpPr>
         <p:spPr>
           <a:xfrm>
-            <a:off x="2322576" y="2542032"/>
-            <a:ext cx="914400" cy="237744"/>
+            <a:off x="475488" y="2926080"/>
+            <a:ext cx="3803904" cy="201168"/>
           </a:xfrm>
           <a:prstGeom prst="rect">
             <a:avLst/>
@@ -9208,13 +9208,13 @@
           <a:p>
             <a:pPr algn="l"/>
             <a:r>
-              <a:rPr sz="1100" b="0" i="0">
-                <a:solidFill>
-                  <a:srgbClr val="334155"/>
+              <a:rPr sz="800" b="0" i="0">
+                <a:solidFill>
+                  <a:srgbClr val="64748B"/>
                 </a:solidFill>
                 <a:latin typeface="Calibri"/>
               </a:rPr>
-              <a:t>$4,997/mo</a:t>
+              <a:t>Campaign build, tracking setup, and account configuration</a:t>
             </a:r>
           </a:p>
         </p:txBody>
@@ -9227,14 +9227,14 @@
         </p:nvSpPr>
         <p:spPr>
           <a:xfrm>
-            <a:off x="2322576" y="2642615"/>
-            <a:ext cx="804672" cy="9144"/>
+            <a:off x="201168" y="3255264"/>
+            <a:ext cx="4133087" cy="402336"/>
           </a:xfrm>
           <a:prstGeom prst="rect">
             <a:avLst/>
           </a:prstGeom>
           <a:solidFill>
-            <a:srgbClr val="334155"/>
+            <a:srgbClr val="EEF2F8"/>
           </a:solidFill>
           <a:ln>
             <a:solidFill>
@@ -9272,8 +9272,8 @@
         </p:nvSpPr>
         <p:spPr>
           <a:xfrm>
-            <a:off x="475488" y="2907791"/>
-            <a:ext cx="3803904" cy="201168"/>
+            <a:off x="329184" y="3282696"/>
+            <a:ext cx="3931920" cy="347472"/>
           </a:xfrm>
           <a:prstGeom prst="rect">
             <a:avLst/>
@@ -9292,7 +9292,7 @@
                 </a:solidFill>
                 <a:latin typeface="Calibri"/>
               </a:rPr>
-              <a:t>Weekly coaching, PI masterminds, Quarterly workshops</a:t>
+              <a:t>+ Recommended ad spend: $19,500-$50,000/mo paid directly to Google/Meta</a:t>
             </a:r>
           </a:p>
         </p:txBody>
@@ -9305,8 +9305,362 @@
         </p:nvSpPr>
         <p:spPr>
           <a:xfrm>
-            <a:off x="201168" y="3255264"/>
-            <a:ext cx="4133087" cy="658368"/>
+            <a:off x="4535424" y="1024128"/>
+            <a:ext cx="4407408" cy="1316736"/>
+          </a:xfrm>
+          <a:prstGeom prst="rect">
+            <a:avLst/>
+          </a:prstGeom>
+          <a:solidFill>
+            <a:srgbClr val="ECFDF5"/>
+          </a:solidFill>
+          <a:ln>
+            <a:solidFill>
+              <a:srgbClr val="FFFFFF"/>
+            </a:solidFill>
+          </a:ln>
+        </p:spPr>
+        <p:style>
+          <a:lnRef idx="1">
+            <a:schemeClr val="accent1"/>
+          </a:lnRef>
+          <a:fillRef idx="3">
+            <a:schemeClr val="accent1"/>
+          </a:fillRef>
+          <a:effectRef idx="2">
+            <a:schemeClr val="accent1"/>
+          </a:effectRef>
+          <a:fontRef idx="minor">
+            <a:schemeClr val="lt1"/>
+          </a:fontRef>
+        </p:style>
+        <p:txBody>
+          <a:bodyPr rtlCol="0" anchor="ctr"/>
+          <a:lstStyle/>
+          <a:p>
+            <a:pPr algn="ctr"/>
+          </a:p>
+        </p:txBody>
+      </p:sp>
+      <p:sp>
+        <p:nvSpPr>
+          <p:cNvPr id="22" name="TextBox 21"/>
+          <p:cNvSpPr txBox="1"/>
+          <p:nvPr/>
+        </p:nvSpPr>
+        <p:spPr>
+          <a:xfrm>
+            <a:off x="4700016" y="1078992"/>
+            <a:ext cx="4133087" cy="219456"/>
+          </a:xfrm>
+          <a:prstGeom prst="rect">
+            <a:avLst/>
+          </a:prstGeom>
+          <a:noFill/>
+        </p:spPr>
+        <p:txBody>
+          <a:bodyPr wrap="square"/>
+          <a:lstStyle/>
+          <a:p>
+            <a:pPr algn="l"/>
+            <a:r>
+              <a:rPr sz="800" b="1" i="0">
+                <a:solidFill>
+                  <a:srgbClr val="065F46"/>
+                </a:solidFill>
+                <a:latin typeface="Calibri"/>
+              </a:rPr>
+              <a:t>PROJECTED RETURN ON AD SPEND</a:t>
+            </a:r>
+          </a:p>
+        </p:txBody>
+      </p:sp>
+      <p:sp>
+        <p:nvSpPr>
+          <p:cNvPr id="23" name="TextBox 22"/>
+          <p:cNvSpPr txBox="1"/>
+          <p:nvPr/>
+        </p:nvSpPr>
+        <p:spPr>
+          <a:xfrm>
+            <a:off x="4700016" y="1335024"/>
+            <a:ext cx="1920240" cy="256032"/>
+          </a:xfrm>
+          <a:prstGeom prst="rect">
+            <a:avLst/>
+          </a:prstGeom>
+          <a:noFill/>
+        </p:spPr>
+        <p:txBody>
+          <a:bodyPr wrap="square"/>
+          <a:lstStyle/>
+          <a:p>
+            <a:pPr algn="l"/>
+            <a:r>
+              <a:rPr sz="900" b="1" i="0">
+                <a:solidFill>
+                  <a:srgbClr val="1E293B"/>
+                </a:solidFill>
+                <a:latin typeface="Calibri"/>
+              </a:rPr>
+              <a:t>Average case value:</a:t>
+            </a:r>
+          </a:p>
+        </p:txBody>
+      </p:sp>
+      <p:sp>
+        <p:nvSpPr>
+          <p:cNvPr id="24" name="TextBox 23"/>
+          <p:cNvSpPr txBox="1"/>
+          <p:nvPr/>
+        </p:nvSpPr>
+        <p:spPr>
+          <a:xfrm>
+            <a:off x="6729984" y="1335024"/>
+            <a:ext cx="2103120" cy="256032"/>
+          </a:xfrm>
+          <a:prstGeom prst="rect">
+            <a:avLst/>
+          </a:prstGeom>
+          <a:noFill/>
+        </p:spPr>
+        <p:txBody>
+          <a:bodyPr wrap="square"/>
+          <a:lstStyle/>
+          <a:p>
+            <a:pPr algn="l"/>
+            <a:r>
+              <a:rPr sz="900" b="0" i="0">
+                <a:solidFill>
+                  <a:srgbClr val="065F46"/>
+                </a:solidFill>
+                <a:latin typeface="Calibri"/>
+              </a:rPr>
+              <a:t>$50,000</a:t>
+            </a:r>
+          </a:p>
+        </p:txBody>
+      </p:sp>
+      <p:sp>
+        <p:nvSpPr>
+          <p:cNvPr id="25" name="Rectangle 24"/>
+          <p:cNvSpPr/>
+          <p:nvPr/>
+        </p:nvSpPr>
+        <p:spPr>
+          <a:xfrm>
+            <a:off x="4645152" y="1609344"/>
+            <a:ext cx="4187952" cy="310896"/>
+          </a:xfrm>
+          <a:prstGeom prst="rect">
+            <a:avLst/>
+          </a:prstGeom>
+          <a:solidFill>
+            <a:srgbClr val="D1FAE5"/>
+          </a:solidFill>
+          <a:ln>
+            <a:solidFill>
+              <a:srgbClr val="FFFFFF"/>
+            </a:solidFill>
+          </a:ln>
+        </p:spPr>
+        <p:style>
+          <a:lnRef idx="1">
+            <a:schemeClr val="accent1"/>
+          </a:lnRef>
+          <a:fillRef idx="3">
+            <a:schemeClr val="accent1"/>
+          </a:fillRef>
+          <a:effectRef idx="2">
+            <a:schemeClr val="accent1"/>
+          </a:effectRef>
+          <a:fontRef idx="minor">
+            <a:schemeClr val="lt1"/>
+          </a:fontRef>
+        </p:style>
+        <p:txBody>
+          <a:bodyPr rtlCol="0" anchor="ctr"/>
+          <a:lstStyle/>
+          <a:p>
+            <a:pPr algn="ctr"/>
+          </a:p>
+        </p:txBody>
+      </p:sp>
+      <p:sp>
+        <p:nvSpPr>
+          <p:cNvPr id="26" name="TextBox 25"/>
+          <p:cNvSpPr txBox="1"/>
+          <p:nvPr/>
+        </p:nvSpPr>
+        <p:spPr>
+          <a:xfrm>
+            <a:off x="4700016" y="1645920"/>
+            <a:ext cx="1920240" cy="256032"/>
+          </a:xfrm>
+          <a:prstGeom prst="rect">
+            <a:avLst/>
+          </a:prstGeom>
+          <a:noFill/>
+        </p:spPr>
+        <p:txBody>
+          <a:bodyPr wrap="square"/>
+          <a:lstStyle/>
+          <a:p>
+            <a:pPr algn="l"/>
+            <a:r>
+              <a:rPr sz="900" b="1" i="0">
+                <a:solidFill>
+                  <a:srgbClr val="1E293B"/>
+                </a:solidFill>
+                <a:latin typeface="Calibri"/>
+              </a:rPr>
+              <a:t>Conservative  (6 cases/mo):</a:t>
+            </a:r>
+          </a:p>
+        </p:txBody>
+      </p:sp>
+      <p:sp>
+        <p:nvSpPr>
+          <p:cNvPr id="27" name="TextBox 26"/>
+          <p:cNvSpPr txBox="1"/>
+          <p:nvPr/>
+        </p:nvSpPr>
+        <p:spPr>
+          <a:xfrm>
+            <a:off x="6729984" y="1645920"/>
+            <a:ext cx="2103120" cy="256032"/>
+          </a:xfrm>
+          <a:prstGeom prst="rect">
+            <a:avLst/>
+          </a:prstGeom>
+          <a:noFill/>
+        </p:spPr>
+        <p:txBody>
+          <a:bodyPr wrap="square"/>
+          <a:lstStyle/>
+          <a:p>
+            <a:pPr algn="l"/>
+            <a:r>
+              <a:rPr sz="900" b="1" i="0">
+                <a:solidFill>
+                  <a:srgbClr val="065F46"/>
+                </a:solidFill>
+                <a:latin typeface="Calibri"/>
+              </a:rPr>
+              <a:t>$300,000 revenue  15x ROAS</a:t>
+            </a:r>
+          </a:p>
+        </p:txBody>
+      </p:sp>
+      <p:sp>
+        <p:nvSpPr>
+          <p:cNvPr id="28" name="TextBox 27"/>
+          <p:cNvSpPr txBox="1"/>
+          <p:nvPr/>
+        </p:nvSpPr>
+        <p:spPr>
+          <a:xfrm>
+            <a:off x="4700016" y="1956816"/>
+            <a:ext cx="1920240" cy="256032"/>
+          </a:xfrm>
+          <a:prstGeom prst="rect">
+            <a:avLst/>
+          </a:prstGeom>
+          <a:noFill/>
+        </p:spPr>
+        <p:txBody>
+          <a:bodyPr wrap="square"/>
+          <a:lstStyle/>
+          <a:p>
+            <a:pPr algn="l"/>
+            <a:r>
+              <a:rPr sz="900" b="1" i="0">
+                <a:solidFill>
+                  <a:srgbClr val="1E293B"/>
+                </a:solidFill>
+                <a:latin typeface="Calibri"/>
+              </a:rPr>
+              <a:t>Aggressive  (17 cases/mo):</a:t>
+            </a:r>
+          </a:p>
+        </p:txBody>
+      </p:sp>
+      <p:sp>
+        <p:nvSpPr>
+          <p:cNvPr id="29" name="TextBox 28"/>
+          <p:cNvSpPr txBox="1"/>
+          <p:nvPr/>
+        </p:nvSpPr>
+        <p:spPr>
+          <a:xfrm>
+            <a:off x="6729984" y="1956816"/>
+            <a:ext cx="2103120" cy="256032"/>
+          </a:xfrm>
+          <a:prstGeom prst="rect">
+            <a:avLst/>
+          </a:prstGeom>
+          <a:noFill/>
+        </p:spPr>
+        <p:txBody>
+          <a:bodyPr wrap="square"/>
+          <a:lstStyle/>
+          <a:p>
+            <a:pPr algn="l"/>
+            <a:r>
+              <a:rPr sz="900" b="1" i="0">
+                <a:solidFill>
+                  <a:srgbClr val="065F46"/>
+                </a:solidFill>
+                <a:latin typeface="Calibri"/>
+              </a:rPr>
+              <a:t>$850,000 revenue  17x ROAS</a:t>
+            </a:r>
+          </a:p>
+        </p:txBody>
+      </p:sp>
+      <p:sp>
+        <p:nvSpPr>
+          <p:cNvPr id="30" name="TextBox 29"/>
+          <p:cNvSpPr txBox="1"/>
+          <p:nvPr/>
+        </p:nvSpPr>
+        <p:spPr>
+          <a:xfrm>
+            <a:off x="4535424" y="2468880"/>
+            <a:ext cx="4407408" cy="237744"/>
+          </a:xfrm>
+          <a:prstGeom prst="rect">
+            <a:avLst/>
+          </a:prstGeom>
+          <a:noFill/>
+        </p:spPr>
+        <p:txBody>
+          <a:bodyPr wrap="square"/>
+          <a:lstStyle/>
+          <a:p>
+            <a:pPr algn="l"/>
+            <a:r>
+              <a:rPr sz="800" b="1" i="0">
+                <a:solidFill>
+                  <a:srgbClr val="0D1F3C"/>
+                </a:solidFill>
+                <a:latin typeface="Calibri"/>
+              </a:rPr>
+              <a:t>WHAT HAPPENS IN THE FIRST 90 DAYS</a:t>
+            </a:r>
+          </a:p>
+        </p:txBody>
+      </p:sp>
+      <p:sp>
+        <p:nvSpPr>
+          <p:cNvPr id="31" name="Rectangle 30"/>
+          <p:cNvSpPr/>
+          <p:nvPr/>
+        </p:nvSpPr>
+        <p:spPr>
+          <a:xfrm>
+            <a:off x="4590288" y="2724912"/>
+            <a:ext cx="256032" cy="256032"/>
           </a:xfrm>
           <a:prstGeom prst="rect">
             <a:avLst/>
@@ -9344,14 +9698,14 @@
       </p:sp>
       <p:sp>
         <p:nvSpPr>
-          <p:cNvPr id="22" name="TextBox 21"/>
+          <p:cNvPr id="32" name="TextBox 31"/>
           <p:cNvSpPr txBox="1"/>
           <p:nvPr/>
         </p:nvSpPr>
         <p:spPr>
           <a:xfrm>
-            <a:off x="384048" y="3291840"/>
-            <a:ext cx="1645920" cy="237744"/>
+            <a:off x="4937760" y="2734056"/>
+            <a:ext cx="804672" cy="256032"/>
           </a:xfrm>
           <a:prstGeom prst="rect">
             <a:avLst/>
@@ -9366,25 +9720,25 @@
             <a:r>
               <a:rPr sz="800" b="1" i="0">
                 <a:solidFill>
-                  <a:srgbClr val="7CA0C0"/>
+                  <a:srgbClr val="0D1F3C"/>
                 </a:solidFill>
                 <a:latin typeface="Calibri"/>
               </a:rPr>
-              <a:t>BUNDLE TOTAL</a:t>
-            </a:r>
-          </a:p>
-        </p:txBody>
-      </p:sp>
-      <p:sp>
-        <p:nvSpPr>
-          <p:cNvPr id="23" name="TextBox 22"/>
+              <a:t>Day 1</a:t>
+            </a:r>
+          </a:p>
+        </p:txBody>
+      </p:sp>
+      <p:sp>
+        <p:nvSpPr>
+          <p:cNvPr id="33" name="TextBox 32"/>
           <p:cNvSpPr txBox="1"/>
           <p:nvPr/>
         </p:nvSpPr>
         <p:spPr>
           <a:xfrm>
-            <a:off x="384048" y="3493008"/>
-            <a:ext cx="2194560" cy="347472"/>
+            <a:off x="5815584" y="2734056"/>
+            <a:ext cx="3054096" cy="256032"/>
           </a:xfrm>
           <a:prstGeom prst="rect">
             <a:avLst/>
@@ -9397,491 +9751,26 @@
           <a:p>
             <a:pPr algn="l"/>
             <a:r>
-              <a:rPr sz="2200" b="1" i="0">
-                <a:solidFill>
-                  <a:srgbClr val="F5C400"/>
+              <a:rPr sz="800" b="0" i="0">
+                <a:solidFill>
+                  <a:srgbClr val="1E293B"/>
                 </a:solidFill>
                 <a:latin typeface="Calibri"/>
               </a:rPr>
-              <a:t>$11,997 / mo</a:t>
-            </a:r>
-          </a:p>
-        </p:txBody>
-      </p:sp>
-      <p:sp>
-        <p:nvSpPr>
-          <p:cNvPr id="24" name="TextBox 23"/>
-          <p:cNvSpPr txBox="1"/>
-          <p:nvPr/>
-        </p:nvSpPr>
-        <p:spPr>
-          <a:xfrm>
-            <a:off x="2670048" y="3493008"/>
-            <a:ext cx="1737360" cy="347472"/>
-          </a:xfrm>
-          <a:prstGeom prst="rect">
-            <a:avLst/>
-          </a:prstGeom>
-          <a:noFill/>
-        </p:spPr>
-        <p:txBody>
-          <a:bodyPr wrap="square"/>
-          <a:lstStyle/>
-          <a:p>
-            <a:pPr algn="l"/>
-            <a:r>
-              <a:rPr sz="800" b="0" i="0">
-                <a:solidFill>
-                  <a:srgbClr val="7CA0C0"/>
-                </a:solidFill>
-                <a:latin typeface="Calibri"/>
-              </a:rPr>
-              <a:t>Save $1,997/mo by bundling</a:t>
-            </a:r>
-          </a:p>
-        </p:txBody>
-      </p:sp>
-      <p:sp>
-        <p:nvSpPr>
-          <p:cNvPr id="25" name="Rectangle 24"/>
+              <a:t>Google Ads &amp; LSA campaigns launched</a:t>
+            </a:r>
+          </a:p>
+        </p:txBody>
+      </p:sp>
+      <p:sp>
+        <p:nvSpPr>
+          <p:cNvPr id="34" name="Rectangle 33"/>
           <p:cNvSpPr/>
           <p:nvPr/>
         </p:nvSpPr>
         <p:spPr>
           <a:xfrm>
-            <a:off x="201168" y="3968496"/>
-            <a:ext cx="4133087" cy="402336"/>
-          </a:xfrm>
-          <a:prstGeom prst="rect">
-            <a:avLst/>
-          </a:prstGeom>
-          <a:solidFill>
-            <a:srgbClr val="EEF2F8"/>
-          </a:solidFill>
-          <a:ln>
-            <a:solidFill>
-              <a:srgbClr val="FFFFFF"/>
-            </a:solidFill>
-          </a:ln>
-        </p:spPr>
-        <p:style>
-          <a:lnRef idx="1">
-            <a:schemeClr val="accent1"/>
-          </a:lnRef>
-          <a:fillRef idx="3">
-            <a:schemeClr val="accent1"/>
-          </a:fillRef>
-          <a:effectRef idx="2">
-            <a:schemeClr val="accent1"/>
-          </a:effectRef>
-          <a:fontRef idx="minor">
-            <a:schemeClr val="lt1"/>
-          </a:fontRef>
-        </p:style>
-        <p:txBody>
-          <a:bodyPr rtlCol="0" anchor="ctr"/>
-          <a:lstStyle/>
-          <a:p>
-            <a:pPr algn="ctr"/>
-          </a:p>
-        </p:txBody>
-      </p:sp>
-      <p:sp>
-        <p:nvSpPr>
-          <p:cNvPr id="26" name="TextBox 25"/>
-          <p:cNvSpPr txBox="1"/>
-          <p:nvPr/>
-        </p:nvSpPr>
-        <p:spPr>
-          <a:xfrm>
-            <a:off x="329184" y="3995928"/>
-            <a:ext cx="3931920" cy="347472"/>
-          </a:xfrm>
-          <a:prstGeom prst="rect">
-            <a:avLst/>
-          </a:prstGeom>
-          <a:noFill/>
-        </p:spPr>
-        <p:txBody>
-          <a:bodyPr wrap="square"/>
-          <a:lstStyle/>
-          <a:p>
-            <a:pPr algn="l"/>
-            <a:r>
-              <a:rPr sz="800" b="0" i="0">
-                <a:solidFill>
-                  <a:srgbClr val="64748B"/>
-                </a:solidFill>
-                <a:latin typeface="Calibri"/>
-              </a:rPr>
-              <a:t>+ Recommended ad spend: $19,500-$50,000/mo paid directly to Google/Meta</a:t>
-            </a:r>
-          </a:p>
-        </p:txBody>
-      </p:sp>
-      <p:sp>
-        <p:nvSpPr>
-          <p:cNvPr id="27" name="Rectangle 26"/>
-          <p:cNvSpPr/>
-          <p:nvPr/>
-        </p:nvSpPr>
-        <p:spPr>
-          <a:xfrm>
-            <a:off x="4535424" y="1024128"/>
-            <a:ext cx="4407408" cy="1316736"/>
-          </a:xfrm>
-          <a:prstGeom prst="rect">
-            <a:avLst/>
-          </a:prstGeom>
-          <a:solidFill>
-            <a:srgbClr val="ECFDF5"/>
-          </a:solidFill>
-          <a:ln>
-            <a:solidFill>
-              <a:srgbClr val="FFFFFF"/>
-            </a:solidFill>
-          </a:ln>
-        </p:spPr>
-        <p:style>
-          <a:lnRef idx="1">
-            <a:schemeClr val="accent1"/>
-          </a:lnRef>
-          <a:fillRef idx="3">
-            <a:schemeClr val="accent1"/>
-          </a:fillRef>
-          <a:effectRef idx="2">
-            <a:schemeClr val="accent1"/>
-          </a:effectRef>
-          <a:fontRef idx="minor">
-            <a:schemeClr val="lt1"/>
-          </a:fontRef>
-        </p:style>
-        <p:txBody>
-          <a:bodyPr rtlCol="0" anchor="ctr"/>
-          <a:lstStyle/>
-          <a:p>
-            <a:pPr algn="ctr"/>
-          </a:p>
-        </p:txBody>
-      </p:sp>
-      <p:sp>
-        <p:nvSpPr>
-          <p:cNvPr id="28" name="TextBox 27"/>
-          <p:cNvSpPr txBox="1"/>
-          <p:nvPr/>
-        </p:nvSpPr>
-        <p:spPr>
-          <a:xfrm>
-            <a:off x="4700016" y="1078992"/>
-            <a:ext cx="4133087" cy="219456"/>
-          </a:xfrm>
-          <a:prstGeom prst="rect">
-            <a:avLst/>
-          </a:prstGeom>
-          <a:noFill/>
-        </p:spPr>
-        <p:txBody>
-          <a:bodyPr wrap="square"/>
-          <a:lstStyle/>
-          <a:p>
-            <a:pPr algn="l"/>
-            <a:r>
-              <a:rPr sz="800" b="1" i="0">
-                <a:solidFill>
-                  <a:srgbClr val="065F46"/>
-                </a:solidFill>
-                <a:latin typeface="Calibri"/>
-              </a:rPr>
-              <a:t>PROJECTED RETURN ON AD SPEND</a:t>
-            </a:r>
-          </a:p>
-        </p:txBody>
-      </p:sp>
-      <p:sp>
-        <p:nvSpPr>
-          <p:cNvPr id="29" name="TextBox 28"/>
-          <p:cNvSpPr txBox="1"/>
-          <p:nvPr/>
-        </p:nvSpPr>
-        <p:spPr>
-          <a:xfrm>
-            <a:off x="4700016" y="1335024"/>
-            <a:ext cx="1920240" cy="256032"/>
-          </a:xfrm>
-          <a:prstGeom prst="rect">
-            <a:avLst/>
-          </a:prstGeom>
-          <a:noFill/>
-        </p:spPr>
-        <p:txBody>
-          <a:bodyPr wrap="square"/>
-          <a:lstStyle/>
-          <a:p>
-            <a:pPr algn="l"/>
-            <a:r>
-              <a:rPr sz="900" b="1" i="0">
-                <a:solidFill>
-                  <a:srgbClr val="1E293B"/>
-                </a:solidFill>
-                <a:latin typeface="Calibri"/>
-              </a:rPr>
-              <a:t>Average case value:</a:t>
-            </a:r>
-          </a:p>
-        </p:txBody>
-      </p:sp>
-      <p:sp>
-        <p:nvSpPr>
-          <p:cNvPr id="30" name="TextBox 29"/>
-          <p:cNvSpPr txBox="1"/>
-          <p:nvPr/>
-        </p:nvSpPr>
-        <p:spPr>
-          <a:xfrm>
-            <a:off x="6729984" y="1335024"/>
-            <a:ext cx="2103120" cy="256032"/>
-          </a:xfrm>
-          <a:prstGeom prst="rect">
-            <a:avLst/>
-          </a:prstGeom>
-          <a:noFill/>
-        </p:spPr>
-        <p:txBody>
-          <a:bodyPr wrap="square"/>
-          <a:lstStyle/>
-          <a:p>
-            <a:pPr algn="l"/>
-            <a:r>
-              <a:rPr sz="900" b="0" i="0">
-                <a:solidFill>
-                  <a:srgbClr val="065F46"/>
-                </a:solidFill>
-                <a:latin typeface="Calibri"/>
-              </a:rPr>
-              <a:t>$50,000</a:t>
-            </a:r>
-          </a:p>
-        </p:txBody>
-      </p:sp>
-      <p:sp>
-        <p:nvSpPr>
-          <p:cNvPr id="31" name="Rectangle 30"/>
-          <p:cNvSpPr/>
-          <p:nvPr/>
-        </p:nvSpPr>
-        <p:spPr>
-          <a:xfrm>
-            <a:off x="4645152" y="1609344"/>
-            <a:ext cx="4187952" cy="310896"/>
-          </a:xfrm>
-          <a:prstGeom prst="rect">
-            <a:avLst/>
-          </a:prstGeom>
-          <a:solidFill>
-            <a:srgbClr val="D1FAE5"/>
-          </a:solidFill>
-          <a:ln>
-            <a:solidFill>
-              <a:srgbClr val="FFFFFF"/>
-            </a:solidFill>
-          </a:ln>
-        </p:spPr>
-        <p:style>
-          <a:lnRef idx="1">
-            <a:schemeClr val="accent1"/>
-          </a:lnRef>
-          <a:fillRef idx="3">
-            <a:schemeClr val="accent1"/>
-          </a:fillRef>
-          <a:effectRef idx="2">
-            <a:schemeClr val="accent1"/>
-          </a:effectRef>
-          <a:fontRef idx="minor">
-            <a:schemeClr val="lt1"/>
-          </a:fontRef>
-        </p:style>
-        <p:txBody>
-          <a:bodyPr rtlCol="0" anchor="ctr"/>
-          <a:lstStyle/>
-          <a:p>
-            <a:pPr algn="ctr"/>
-          </a:p>
-        </p:txBody>
-      </p:sp>
-      <p:sp>
-        <p:nvSpPr>
-          <p:cNvPr id="32" name="TextBox 31"/>
-          <p:cNvSpPr txBox="1"/>
-          <p:nvPr/>
-        </p:nvSpPr>
-        <p:spPr>
-          <a:xfrm>
-            <a:off x="4700016" y="1645920"/>
-            <a:ext cx="1920240" cy="256032"/>
-          </a:xfrm>
-          <a:prstGeom prst="rect">
-            <a:avLst/>
-          </a:prstGeom>
-          <a:noFill/>
-        </p:spPr>
-        <p:txBody>
-          <a:bodyPr wrap="square"/>
-          <a:lstStyle/>
-          <a:p>
-            <a:pPr algn="l"/>
-            <a:r>
-              <a:rPr sz="900" b="1" i="0">
-                <a:solidFill>
-                  <a:srgbClr val="1E293B"/>
-                </a:solidFill>
-                <a:latin typeface="Calibri"/>
-              </a:rPr>
-              <a:t>Conservative  (6 cases/mo):</a:t>
-            </a:r>
-          </a:p>
-        </p:txBody>
-      </p:sp>
-      <p:sp>
-        <p:nvSpPr>
-          <p:cNvPr id="33" name="TextBox 32"/>
-          <p:cNvSpPr txBox="1"/>
-          <p:nvPr/>
-        </p:nvSpPr>
-        <p:spPr>
-          <a:xfrm>
-            <a:off x="6729984" y="1645920"/>
-            <a:ext cx="2103120" cy="256032"/>
-          </a:xfrm>
-          <a:prstGeom prst="rect">
-            <a:avLst/>
-          </a:prstGeom>
-          <a:noFill/>
-        </p:spPr>
-        <p:txBody>
-          <a:bodyPr wrap="square"/>
-          <a:lstStyle/>
-          <a:p>
-            <a:pPr algn="l"/>
-            <a:r>
-              <a:rPr sz="900" b="1" i="0">
-                <a:solidFill>
-                  <a:srgbClr val="065F46"/>
-                </a:solidFill>
-                <a:latin typeface="Calibri"/>
-              </a:rPr>
-              <a:t>$300,000 revenue  15x ROAS</a:t>
-            </a:r>
-          </a:p>
-        </p:txBody>
-      </p:sp>
-      <p:sp>
-        <p:nvSpPr>
-          <p:cNvPr id="34" name="TextBox 33"/>
-          <p:cNvSpPr txBox="1"/>
-          <p:nvPr/>
-        </p:nvSpPr>
-        <p:spPr>
-          <a:xfrm>
-            <a:off x="4700016" y="1956816"/>
-            <a:ext cx="1920240" cy="256032"/>
-          </a:xfrm>
-          <a:prstGeom prst="rect">
-            <a:avLst/>
-          </a:prstGeom>
-          <a:noFill/>
-        </p:spPr>
-        <p:txBody>
-          <a:bodyPr wrap="square"/>
-          <a:lstStyle/>
-          <a:p>
-            <a:pPr algn="l"/>
-            <a:r>
-              <a:rPr sz="900" b="1" i="0">
-                <a:solidFill>
-                  <a:srgbClr val="1E293B"/>
-                </a:solidFill>
-                <a:latin typeface="Calibri"/>
-              </a:rPr>
-              <a:t>Aggressive  (17 cases/mo):</a:t>
-            </a:r>
-          </a:p>
-        </p:txBody>
-      </p:sp>
-      <p:sp>
-        <p:nvSpPr>
-          <p:cNvPr id="35" name="TextBox 34"/>
-          <p:cNvSpPr txBox="1"/>
-          <p:nvPr/>
-        </p:nvSpPr>
-        <p:spPr>
-          <a:xfrm>
-            <a:off x="6729984" y="1956816"/>
-            <a:ext cx="2103120" cy="256032"/>
-          </a:xfrm>
-          <a:prstGeom prst="rect">
-            <a:avLst/>
-          </a:prstGeom>
-          <a:noFill/>
-        </p:spPr>
-        <p:txBody>
-          <a:bodyPr wrap="square"/>
-          <a:lstStyle/>
-          <a:p>
-            <a:pPr algn="l"/>
-            <a:r>
-              <a:rPr sz="900" b="1" i="0">
-                <a:solidFill>
-                  <a:srgbClr val="065F46"/>
-                </a:solidFill>
-                <a:latin typeface="Calibri"/>
-              </a:rPr>
-              <a:t>$850,000 revenue  17x ROAS</a:t>
-            </a:r>
-          </a:p>
-        </p:txBody>
-      </p:sp>
-      <p:sp>
-        <p:nvSpPr>
-          <p:cNvPr id="36" name="TextBox 35"/>
-          <p:cNvSpPr txBox="1"/>
-          <p:nvPr/>
-        </p:nvSpPr>
-        <p:spPr>
-          <a:xfrm>
-            <a:off x="4535424" y="2468880"/>
-            <a:ext cx="4407408" cy="237744"/>
-          </a:xfrm>
-          <a:prstGeom prst="rect">
-            <a:avLst/>
-          </a:prstGeom>
-          <a:noFill/>
-        </p:spPr>
-        <p:txBody>
-          <a:bodyPr wrap="square"/>
-          <a:lstStyle/>
-          <a:p>
-            <a:pPr algn="l"/>
-            <a:r>
-              <a:rPr sz="800" b="1" i="0">
-                <a:solidFill>
-                  <a:srgbClr val="0D1F3C"/>
-                </a:solidFill>
-                <a:latin typeface="Calibri"/>
-              </a:rPr>
-              <a:t>WHAT HAPPENS IN THE FIRST 90 DAYS</a:t>
-            </a:r>
-          </a:p>
-        </p:txBody>
-      </p:sp>
-      <p:sp>
-        <p:nvSpPr>
-          <p:cNvPr id="37" name="Rectangle 36"/>
-          <p:cNvSpPr/>
-          <p:nvPr/>
-        </p:nvSpPr>
-        <p:spPr>
-          <a:xfrm>
-            <a:off x="4590288" y="2724912"/>
+            <a:off x="4590288" y="3081528"/>
             <a:ext cx="256032" cy="256032"/>
           </a:xfrm>
           <a:prstGeom prst="rect">
@@ -9920,13 +9809,13 @@
       </p:sp>
       <p:sp>
         <p:nvSpPr>
-          <p:cNvPr id="38" name="TextBox 37"/>
+          <p:cNvPr id="35" name="TextBox 34"/>
           <p:cNvSpPr txBox="1"/>
           <p:nvPr/>
         </p:nvSpPr>
         <p:spPr>
           <a:xfrm>
-            <a:off x="4937760" y="2734056"/>
+            <a:off x="4937760" y="3090672"/>
             <a:ext cx="804672" cy="256032"/>
           </a:xfrm>
           <a:prstGeom prst="rect">
@@ -9946,20 +9835,20 @@
                 </a:solidFill>
                 <a:latin typeface="Calibri"/>
               </a:rPr>
-              <a:t>Day 1</a:t>
-            </a:r>
-          </a:p>
-        </p:txBody>
-      </p:sp>
-      <p:sp>
-        <p:nvSpPr>
-          <p:cNvPr id="39" name="TextBox 38"/>
+              <a:t>Day 14</a:t>
+            </a:r>
+          </a:p>
+        </p:txBody>
+      </p:sp>
+      <p:sp>
+        <p:nvSpPr>
+          <p:cNvPr id="36" name="TextBox 35"/>
           <p:cNvSpPr txBox="1"/>
           <p:nvPr/>
         </p:nvSpPr>
         <p:spPr>
           <a:xfrm>
-            <a:off x="5815584" y="2734056"/>
+            <a:off x="5815584" y="3090672"/>
             <a:ext cx="3054096" cy="256032"/>
           </a:xfrm>
           <a:prstGeom prst="rect">
@@ -9979,20 +9868,20 @@
                 </a:solidFill>
                 <a:latin typeface="Calibri"/>
               </a:rPr>
-              <a:t>Google Ads &amp; LSA campaigns launched</a:t>
-            </a:r>
-          </a:p>
-        </p:txBody>
-      </p:sp>
-      <p:sp>
-        <p:nvSpPr>
-          <p:cNvPr id="40" name="Rectangle 39"/>
+              <a:t>NAP corrections across all directories</a:t>
+            </a:r>
+          </a:p>
+        </p:txBody>
+      </p:sp>
+      <p:sp>
+        <p:nvSpPr>
+          <p:cNvPr id="37" name="Rectangle 36"/>
           <p:cNvSpPr/>
           <p:nvPr/>
         </p:nvSpPr>
         <p:spPr>
           <a:xfrm>
-            <a:off x="4590288" y="3081528"/>
+            <a:off x="4590288" y="3438144"/>
             <a:ext cx="256032" cy="256032"/>
           </a:xfrm>
           <a:prstGeom prst="rect">
@@ -10031,13 +9920,13 @@
       </p:sp>
       <p:sp>
         <p:nvSpPr>
-          <p:cNvPr id="41" name="TextBox 40"/>
+          <p:cNvPr id="38" name="TextBox 37"/>
           <p:cNvSpPr txBox="1"/>
           <p:nvPr/>
         </p:nvSpPr>
         <p:spPr>
           <a:xfrm>
-            <a:off x="4937760" y="3090672"/>
+            <a:off x="4937760" y="3447287"/>
             <a:ext cx="804672" cy="256032"/>
           </a:xfrm>
           <a:prstGeom prst="rect">
@@ -10057,20 +9946,20 @@
                 </a:solidFill>
                 <a:latin typeface="Calibri"/>
               </a:rPr>
-              <a:t>Day 14</a:t>
-            </a:r>
-          </a:p>
-        </p:txBody>
-      </p:sp>
-      <p:sp>
-        <p:nvSpPr>
-          <p:cNvPr id="42" name="TextBox 41"/>
+              <a:t>Week 2</a:t>
+            </a:r>
+          </a:p>
+        </p:txBody>
+      </p:sp>
+      <p:sp>
+        <p:nvSpPr>
+          <p:cNvPr id="39" name="TextBox 38"/>
           <p:cNvSpPr txBox="1"/>
           <p:nvPr/>
         </p:nvSpPr>
         <p:spPr>
           <a:xfrm>
-            <a:off x="5815584" y="3090672"/>
+            <a:off x="5815584" y="3447287"/>
             <a:ext cx="3054096" cy="256032"/>
           </a:xfrm>
           <a:prstGeom prst="rect">
@@ -10090,20 +9979,20 @@
                 </a:solidFill>
                 <a:latin typeface="Calibri"/>
               </a:rPr>
-              <a:t>NAP corrections across all directories</a:t>
-            </a:r>
-          </a:p>
-        </p:txBody>
-      </p:sp>
-      <p:sp>
-        <p:nvSpPr>
-          <p:cNvPr id="43" name="Rectangle 42"/>
+              <a:t>Above-fold form + Katy/Sugar Land pages live</a:t>
+            </a:r>
+          </a:p>
+        </p:txBody>
+      </p:sp>
+      <p:sp>
+        <p:nvSpPr>
+          <p:cNvPr id="40" name="Rectangle 39"/>
           <p:cNvSpPr/>
           <p:nvPr/>
         </p:nvSpPr>
         <p:spPr>
           <a:xfrm>
-            <a:off x="4590288" y="3438144"/>
+            <a:off x="4590288" y="3794760"/>
             <a:ext cx="256032" cy="256032"/>
           </a:xfrm>
           <a:prstGeom prst="rect">
@@ -10142,13 +10031,13 @@
       </p:sp>
       <p:sp>
         <p:nvSpPr>
-          <p:cNvPr id="44" name="TextBox 43"/>
+          <p:cNvPr id="41" name="TextBox 40"/>
           <p:cNvSpPr txBox="1"/>
           <p:nvPr/>
         </p:nvSpPr>
         <p:spPr>
           <a:xfrm>
-            <a:off x="4937760" y="3447287"/>
+            <a:off x="4937760" y="3803904"/>
             <a:ext cx="804672" cy="256032"/>
           </a:xfrm>
           <a:prstGeom prst="rect">
@@ -10168,20 +10057,20 @@
                 </a:solidFill>
                 <a:latin typeface="Calibri"/>
               </a:rPr>
-              <a:t>Week 2</a:t>
-            </a:r>
-          </a:p>
-        </p:txBody>
-      </p:sp>
-      <p:sp>
-        <p:nvSpPr>
-          <p:cNvPr id="45" name="TextBox 44"/>
+              <a:t>Week 3</a:t>
+            </a:r>
+          </a:p>
+        </p:txBody>
+      </p:sp>
+      <p:sp>
+        <p:nvSpPr>
+          <p:cNvPr id="42" name="TextBox 41"/>
           <p:cNvSpPr txBox="1"/>
           <p:nvPr/>
         </p:nvSpPr>
         <p:spPr>
           <a:xfrm>
-            <a:off x="5815584" y="3447287"/>
+            <a:off x="5815584" y="3803904"/>
             <a:ext cx="3054096" cy="256032"/>
           </a:xfrm>
           <a:prstGeom prst="rect">
@@ -10201,20 +10090,20 @@
                 </a:solidFill>
                 <a:latin typeface="Calibri"/>
               </a:rPr>
-              <a:t>Above-fold form + Katy/Sugar Land pages live</a:t>
-            </a:r>
-          </a:p>
-        </p:txBody>
-      </p:sp>
-      <p:sp>
-        <p:nvSpPr>
-          <p:cNvPr id="46" name="Rectangle 45"/>
+              <a:t>Google review request system activated</a:t>
+            </a:r>
+          </a:p>
+        </p:txBody>
+      </p:sp>
+      <p:sp>
+        <p:nvSpPr>
+          <p:cNvPr id="43" name="Rectangle 42"/>
           <p:cNvSpPr/>
           <p:nvPr/>
         </p:nvSpPr>
         <p:spPr>
           <a:xfrm>
-            <a:off x="4590288" y="3794760"/>
+            <a:off x="4590288" y="4151376"/>
             <a:ext cx="256032" cy="256032"/>
           </a:xfrm>
           <a:prstGeom prst="rect">
@@ -10253,13 +10142,13 @@
       </p:sp>
       <p:sp>
         <p:nvSpPr>
-          <p:cNvPr id="47" name="TextBox 46"/>
+          <p:cNvPr id="44" name="TextBox 43"/>
           <p:cNvSpPr txBox="1"/>
           <p:nvPr/>
         </p:nvSpPr>
         <p:spPr>
           <a:xfrm>
-            <a:off x="4937760" y="3803904"/>
+            <a:off x="4937760" y="4160520"/>
             <a:ext cx="804672" cy="256032"/>
           </a:xfrm>
           <a:prstGeom prst="rect">
@@ -10279,20 +10168,20 @@
                 </a:solidFill>
                 <a:latin typeface="Calibri"/>
               </a:rPr>
-              <a:t>Week 3</a:t>
-            </a:r>
-          </a:p>
-        </p:txBody>
-      </p:sp>
-      <p:sp>
-        <p:nvSpPr>
-          <p:cNvPr id="48" name="TextBox 47"/>
+              <a:t>Month 3</a:t>
+            </a:r>
+          </a:p>
+        </p:txBody>
+      </p:sp>
+      <p:sp>
+        <p:nvSpPr>
+          <p:cNvPr id="45" name="TextBox 44"/>
           <p:cNvSpPr txBox="1"/>
           <p:nvPr/>
         </p:nvSpPr>
         <p:spPr>
           <a:xfrm>
-            <a:off x="5815584" y="3803904"/>
+            <a:off x="5815584" y="4160520"/>
             <a:ext cx="3054096" cy="256032"/>
           </a:xfrm>
           <a:prstGeom prst="rect">
@@ -10312,21 +10201,21 @@
                 </a:solidFill>
                 <a:latin typeface="Calibri"/>
               </a:rPr>
-              <a:t>Google review request system activated</a:t>
-            </a:r>
-          </a:p>
-        </p:txBody>
-      </p:sp>
-      <p:sp>
-        <p:nvSpPr>
-          <p:cNvPr id="49" name="Rectangle 48"/>
+              <a:t>ROI dashboard live + review velocity targets set</a:t>
+            </a:r>
+          </a:p>
+        </p:txBody>
+      </p:sp>
+      <p:sp>
+        <p:nvSpPr>
+          <p:cNvPr id="46" name="Rectangle 45"/>
           <p:cNvSpPr/>
           <p:nvPr/>
         </p:nvSpPr>
         <p:spPr>
           <a:xfrm>
-            <a:off x="4590288" y="4151376"/>
-            <a:ext cx="256032" cy="256032"/>
+            <a:off x="0" y="4425696"/>
+            <a:ext cx="9144000" cy="402336"/>
           </a:xfrm>
           <a:prstGeom prst="rect">
             <a:avLst/>
@@ -10364,14 +10253,14 @@
       </p:sp>
       <p:sp>
         <p:nvSpPr>
-          <p:cNvPr id="50" name="TextBox 49"/>
+          <p:cNvPr id="47" name="TextBox 46"/>
           <p:cNvSpPr txBox="1"/>
           <p:nvPr/>
         </p:nvSpPr>
         <p:spPr>
           <a:xfrm>
-            <a:off x="4937760" y="4160520"/>
-            <a:ext cx="804672" cy="256032"/>
+            <a:off x="274320" y="4425696"/>
+            <a:ext cx="8595360" cy="402336"/>
           </a:xfrm>
           <a:prstGeom prst="rect">
             <a:avLst/>
@@ -10382,62 +10271,29 @@
           <a:bodyPr wrap="square"/>
           <a:lstStyle/>
           <a:p>
-            <a:pPr algn="l"/>
-            <a:r>
-              <a:rPr sz="800" b="1" i="0">
-                <a:solidFill>
-                  <a:srgbClr val="0D1F3C"/>
+            <a:pPr algn="ctr"/>
+            <a:r>
+              <a:rPr sz="900" b="0" i="1">
+                <a:solidFill>
+                  <a:srgbClr val="8BADD0"/>
                 </a:solidFill>
                 <a:latin typeface="Calibri"/>
               </a:rPr>
-              <a:t>Month 3</a:t>
-            </a:r>
-          </a:p>
-        </p:txBody>
-      </p:sp>
-      <p:sp>
-        <p:nvSpPr>
-          <p:cNvPr id="51" name="TextBox 50"/>
-          <p:cNvSpPr txBox="1"/>
-          <p:nvPr/>
-        </p:nvSpPr>
-        <p:spPr>
-          <a:xfrm>
-            <a:off x="5815584" y="4160520"/>
-            <a:ext cx="3054096" cy="256032"/>
-          </a:xfrm>
-          <a:prstGeom prst="rect">
-            <a:avLst/>
-          </a:prstGeom>
-          <a:noFill/>
-        </p:spPr>
-        <p:txBody>
-          <a:bodyPr wrap="square"/>
-          <a:lstStyle/>
-          <a:p>
-            <a:pPr algn="l"/>
-            <a:r>
-              <a:rPr sz="800" b="0" i="0">
-                <a:solidFill>
-                  <a:srgbClr val="1E293B"/>
-                </a:solidFill>
-                <a:latin typeface="Calibri"/>
-              </a:rPr>
-              <a:t>Coaching kickoff + case tracking live</a:t>
-            </a:r>
-          </a:p>
-        </p:txBody>
-      </p:sp>
-      <p:sp>
-        <p:nvSpPr>
-          <p:cNvPr id="52" name="Rectangle 51"/>
+              <a:t>"The cases are in this market. The team is already in place. The only thing missing is the system that turns this firm's reputation into revenue -- and that is exactly what we build."</a:t>
+            </a:r>
+          </a:p>
+        </p:txBody>
+      </p:sp>
+      <p:sp>
+        <p:nvSpPr>
+          <p:cNvPr id="48" name="Rectangle 47"/>
           <p:cNvSpPr/>
           <p:nvPr/>
         </p:nvSpPr>
         <p:spPr>
           <a:xfrm>
-            <a:off x="0" y="4425696"/>
-            <a:ext cx="9144000" cy="402336"/>
+            <a:off x="0" y="4828032"/>
+            <a:ext cx="9144000" cy="320040"/>
           </a:xfrm>
           <a:prstGeom prst="rect">
             <a:avLst/>
@@ -10473,87 +10329,9 @@
           </a:p>
         </p:txBody>
       </p:sp>
-      <p:sp>
-        <p:nvSpPr>
-          <p:cNvPr id="53" name="TextBox 52"/>
-          <p:cNvSpPr txBox="1"/>
-          <p:nvPr/>
-        </p:nvSpPr>
-        <p:spPr>
-          <a:xfrm>
-            <a:off x="274320" y="4425696"/>
-            <a:ext cx="8595360" cy="402336"/>
-          </a:xfrm>
-          <a:prstGeom prst="rect">
-            <a:avLst/>
-          </a:prstGeom>
-          <a:noFill/>
-        </p:spPr>
-        <p:txBody>
-          <a:bodyPr wrap="square"/>
-          <a:lstStyle/>
-          <a:p>
-            <a:pPr algn="ctr"/>
-            <a:r>
-              <a:rPr sz="900" b="0" i="1">
-                <a:solidFill>
-                  <a:srgbClr val="8BADD0"/>
-                </a:solidFill>
-                <a:latin typeface="Calibri"/>
-              </a:rPr>
-              <a:t>"The cases are in this market. The team is already in place. The only thing missing is the system that turns this firm's reputation into revenue -- and that is exactly what we build."</a:t>
-            </a:r>
-          </a:p>
-        </p:txBody>
-      </p:sp>
-      <p:sp>
-        <p:nvSpPr>
-          <p:cNvPr id="54" name="Rectangle 53"/>
-          <p:cNvSpPr/>
-          <p:nvPr/>
-        </p:nvSpPr>
-        <p:spPr>
-          <a:xfrm>
-            <a:off x="0" y="4828032"/>
-            <a:ext cx="9144000" cy="320040"/>
-          </a:xfrm>
-          <a:prstGeom prst="rect">
-            <a:avLst/>
-          </a:prstGeom>
-          <a:solidFill>
-            <a:srgbClr val="0D1F3C"/>
-          </a:solidFill>
-          <a:ln>
-            <a:solidFill>
-              <a:srgbClr val="FFFFFF"/>
-            </a:solidFill>
-          </a:ln>
-        </p:spPr>
-        <p:style>
-          <a:lnRef idx="1">
-            <a:schemeClr val="accent1"/>
-          </a:lnRef>
-          <a:fillRef idx="3">
-            <a:schemeClr val="accent1"/>
-          </a:fillRef>
-          <a:effectRef idx="2">
-            <a:schemeClr val="accent1"/>
-          </a:effectRef>
-          <a:fontRef idx="minor">
-            <a:schemeClr val="lt1"/>
-          </a:fontRef>
-        </p:style>
-        <p:txBody>
-          <a:bodyPr rtlCol="0" anchor="ctr"/>
-          <a:lstStyle/>
-          <a:p>
-            <a:pPr algn="ctr"/>
-          </a:p>
-        </p:txBody>
-      </p:sp>
       <p:pic>
         <p:nvPicPr>
-          <p:cNvPr id="55" name="Picture 54" descr="smb_team_logo.png"/>
+          <p:cNvPr id="49" name="Picture 48" descr="smb_team_logo.png"/>
           <p:cNvPicPr>
             <a:picLocks noChangeAspect="1"/>
           </p:cNvPicPr>
@@ -10577,7 +10355,7 @@
       </p:pic>
       <p:sp>
         <p:nvSpPr>
-          <p:cNvPr id="56" name="TextBox 55"/>
+          <p:cNvPr id="50" name="TextBox 49"/>
           <p:cNvSpPr txBox="1"/>
           <p:nvPr/>
         </p:nvSpPr>
@@ -10610,7 +10388,7 @@
       </p:sp>
       <p:sp>
         <p:nvSpPr>
-          <p:cNvPr id="57" name="TextBox 56"/>
+          <p:cNvPr id="51" name="TextBox 50"/>
           <p:cNvSpPr txBox="1"/>
           <p:nvPr/>
         </p:nvSpPr>

</xml_diff>

<commit_message>
Update Cox Pradia: standalone price $8,997/mo (remove bundled discount display)
Updated Full Service Marketing — Growth price from bundled $7,397/mo to
standalone $8,997/mo across PPTX slide, executive summary, and investment table.

Co-Authored-By: Claude Sonnet 4.6 <noreply@anthropic.com>
</commit_message>
<xml_diff>
--- a/cox-pradia/TheCoxPradiaLawFirm_May292026_Proposal.pptx
+++ b/cox-pradia/TheCoxPradiaLawFirm_May292026_Proposal.pptx
@@ -8848,7 +8848,7 @@
                 </a:solidFill>
                 <a:latin typeface="Calibri"/>
               </a:rPr>
-              <a:t>$7,397</a:t>
+              <a:t>$8,997</a:t>
             </a:r>
           </a:p>
         </p:txBody>
@@ -8914,7 +8914,7 @@
                 </a:solidFill>
                 <a:latin typeface="Calibri"/>
               </a:rPr>
-              <a:t>$8,997/mo</a:t>
+              <a:t/>
             </a:r>
           </a:p>
         </p:txBody>

</xml_diff>

<commit_message>
Add proposal PPTX: The Cox Pradia Law Firm (May 29, 2026)
Pass 3 complete — 3-slide proposal PPTX generated. Also corrects
Growth package bundled price ($8,997 → $7,397) in exec summary
and index.html investment display.

Co-Authored-By: Claude Sonnet 4.6 <noreply@anthropic.com>
</commit_message>
<xml_diff>
--- a/cox-pradia/TheCoxPradiaLawFirm_May292026_Proposal.pptx
+++ b/cox-pradia/TheCoxPradiaLawFirm_May292026_Proposal.pptx
@@ -3163,7 +3163,7 @@
                 </a:solidFill>
                 <a:latin typeface="Calibri"/>
               </a:rPr>
-              <a:t>LAW FIRM GROWTH AUDIT  -  THE COX PRADIA LAW FIRM</a:t>
+              <a:t>LAW FIRM GROWTH AUDIT  ·  THE COX PRADIA LAW FIRM</a:t>
             </a:r>
           </a:p>
         </p:txBody>
@@ -3541,7 +3541,7 @@
                 </a:solidFill>
                 <a:latin typeface="Calibri"/>
               </a:rPr>
-              <a:t>No ads — invisible</a:t>
+              <a:t>No paid ads — invisible</a:t>
             </a:r>
           </a:p>
         </p:txBody>
@@ -3730,7 +3730,7 @@
                 </a:solidFill>
                 <a:latin typeface="Calibri"/>
               </a:rPr>
-              <a:t>Footer form only</a:t>
+              <a:t>No live chat or after-hrs</a:t>
             </a:r>
           </a:p>
         </p:txBody>
@@ -3919,7 +3919,7 @@
                 </a:solidFill>
                 <a:latin typeface="Calibri"/>
               </a:rPr>
-              <a:t>10-person team built</a:t>
+              <a:t>No mgmt layer in place</a:t>
             </a:r>
           </a:p>
         </p:txBody>
@@ -4108,7 +4108,7 @@
                 </a:solidFill>
                 <a:latin typeface="Calibri"/>
               </a:rPr>
-              <a:t>No revenue data</a:t>
+              <a:t>No revenue visibility</a:t>
             </a:r>
           </a:p>
         </p:txBody>
@@ -4264,7 +4264,7 @@
                 </a:solidFill>
                 <a:latin typeface="Calibri"/>
               </a:rPr>
-              <a:t>X</a:t>
+              <a:t>✕</a:t>
             </a:r>
           </a:p>
         </p:txBody>
@@ -4297,7 +4297,7 @@
                 </a:solidFill>
                 <a:latin typeface="Calibri"/>
               </a:rPr>
-              <a:t>Invisible on paid search — Zehl spends $913K+/yr on Google Ads alone</a:t>
+              <a:t>Invisible on Google Ads + 3-pack while Zehl spends $913K/yr on PI terms</a:t>
             </a:r>
           </a:p>
         </p:txBody>
@@ -4420,7 +4420,7 @@
                 </a:solidFill>
                 <a:latin typeface="Calibri"/>
               </a:rPr>
-              <a:t>X</a:t>
+              <a:t>✕</a:t>
             </a:r>
           </a:p>
         </p:txBody>
@@ -4453,7 +4453,7 @@
                 </a:solidFill>
                 <a:latin typeface="Calibri"/>
               </a:rPr>
-              <a:t>2 addresses + 3 phone numbers hurt Google 3-pack ranking signals</a:t>
+              <a:t>Two addresses + three phone numbers across directories hurt 3-pack ranking</a:t>
             </a:r>
           </a:p>
         </p:txBody>
@@ -4576,7 +4576,7 @@
                 </a:solidFill>
                 <a:latin typeface="Calibri"/>
               </a:rPr>
-              <a:t>X</a:t>
+              <a:t>✕</a:t>
             </a:r>
           </a:p>
         </p:txBody>
@@ -4609,7 +4609,7 @@
                 </a:solidFill>
                 <a:latin typeface="Calibri"/>
               </a:rPr>
-              <a:t>Footer-only form means after-hours visitors leave with no intake path</a:t>
+              <a:t>No live chat + footer-only form — after-hours PI visitors leave unconverted</a:t>
             </a:r>
           </a:p>
         </p:txBody>
@@ -4732,7 +4732,7 @@
                 </a:solidFill>
                 <a:latin typeface="Calibri"/>
               </a:rPr>
-              <a:t>+</a:t>
+              <a:t>✓</a:t>
             </a:r>
           </a:p>
         </p:txBody>
@@ -4765,7 +4765,7 @@
                 </a:solidFill>
                 <a:latin typeface="Calibri"/>
               </a:rPr>
-              <a:t>10-person team with intake coordinators &amp; case manager already in place</a:t>
+              <a:t>Structured 10-person team — intake coordinators + case manager — ready to scale</a:t>
             </a:r>
           </a:p>
         </p:txBody>
@@ -4966,7 +4966,7 @@
                 </a:solidFill>
                 <a:latin typeface="Calibri"/>
               </a:rPr>
-              <a:t>Stage 4: Small Business Manager  -&gt;  Goal: Stage 6, Law Firm Owner</a:t>
+              <a:t>Stage 4: Small Business Manager  →  Stage 6: Law Firm Owner</a:t>
             </a:r>
           </a:p>
         </p:txBody>
@@ -5110,7 +5110,7 @@
                 </a:solidFill>
                 <a:latin typeface="Calibri"/>
               </a:rPr>
-              <a:t>1,262 reviews 5.0</a:t>
+              <a:t>1,262 reviews</a:t>
             </a:r>
           </a:p>
         </p:txBody>
@@ -5143,7 +5143,7 @@
                 </a:solidFill>
                 <a:latin typeface="Calibri"/>
               </a:rPr>
-              <a:t>Google Screened, $913K/yr ads</a:t>
+              <a:t>5.0★ · $913K ads/yr</a:t>
             </a:r>
           </a:p>
         </p:txBody>
@@ -5221,7 +5221,7 @@
                 </a:solidFill>
                 <a:latin typeface="Calibri"/>
               </a:rPr>
-              <a:t>Simmons and Fletcher</a:t>
+              <a:t>Simmons and Fletcher, P.C.</a:t>
             </a:r>
           </a:p>
         </p:txBody>
@@ -5254,7 +5254,7 @@
                 </a:solidFill>
                 <a:latin typeface="Calibri"/>
               </a:rPr>
-              <a:t>502 reviews 4.9</a:t>
+              <a:t>502 reviews</a:t>
             </a:r>
           </a:p>
         </p:txBody>
@@ -5287,7 +5287,7 @@
                 </a:solidFill>
                 <a:latin typeface="Calibri"/>
               </a:rPr>
-              <a:t>Google Screened, $384K/yr ads</a:t>
+              <a:t>4.9★ · $384K ads/yr</a:t>
             </a:r>
           </a:p>
         </p:txBody>
@@ -5398,7 +5398,7 @@
                 </a:solidFill>
                 <a:latin typeface="Calibri"/>
               </a:rPr>
-              <a:t>100 reviews 4.6</a:t>
+              <a:t>100 reviews</a:t>
             </a:r>
           </a:p>
         </p:txBody>
@@ -5431,7 +5431,7 @@
                 </a:solidFill>
                 <a:latin typeface="Calibri"/>
               </a:rPr>
-              <a:t>$272K/yr ads, board certified</a:t>
+              <a:t>4.6★ · $272K ads/yr</a:t>
             </a:r>
           </a:p>
         </p:txBody>
@@ -5587,7 +5587,7 @@
                 </a:solidFill>
                 <a:latin typeface="Calibri"/>
               </a:rPr>
-              <a:t>51 reviews 4.4</a:t>
+              <a:t>51 reviews</a:t>
             </a:r>
           </a:p>
         </p:txBody>
@@ -5620,7 +5620,7 @@
                 </a:solidFill>
                 <a:latin typeface="Calibri"/>
               </a:rPr>
-              <a:t>You are here</a:t>
+              <a:t>← You are here</a:t>
             </a:r>
           </a:p>
         </p:txBody>
@@ -5722,7 +5722,7 @@
                 </a:solidFill>
                 <a:latin typeface="Calibri"/>
               </a:rPr>
-              <a:t>CONFIDENTIAL  -  Prepared by Nick Holderman | SMB Team</a:t>
+              <a:t>CONFIDENTIAL  ·  Prepared by Nick Holderman | SMB Team</a:t>
             </a:r>
           </a:p>
         </p:txBody>
@@ -5851,7 +5851,7 @@
                 </a:solidFill>
                 <a:latin typeface="Calibri"/>
               </a:rPr>
-              <a:t>LAW FIRM GROWTH AUDIT  -  THE COX PRADIA LAW FIRM</a:t>
+              <a:t>LAW FIRM GROWTH AUDIT  ·  THE COX PRADIA LAW FIRM</a:t>
             </a:r>
           </a:p>
         </p:txBody>
@@ -5884,7 +5884,7 @@
                 </a:solidFill>
                 <a:latin typeface="Calibri"/>
               </a:rPr>
-              <a:t>Your Growth Plan: 3 Priorities for The Cox Pradia Law Firm</a:t>
+              <a:t>Your Growth Plan: 3 Priorities to Build a Firm That Runs Without You</a:t>
             </a:r>
           </a:p>
         </p:txBody>
@@ -6040,7 +6040,7 @@
                 </a:solidFill>
                 <a:latin typeface="Calibri"/>
               </a:rPr>
-              <a:t>Lead Generation. Intake. Self-Managing Team. Profit Plan. All four must work together. Cox Pradia has the team and track record. When the marketing engine is added, the firm grows without the partners personally driving every case.</a:t>
+              <a:t>Four pillars power every thriving law firm: Lead Generation, Intake, Team, and Profit. Today, Cox Pradia has the team and the talent — but two pillars are red and two are amber. This plan builds what is missing. When all four pillars work together, Cox and Pradia can step back from daily operations and let the firm generate the cases, the revenue, and the freedom their 40 years of work have earned.</a:t>
             </a:r>
           </a:p>
         </p:txBody>
@@ -6118,7 +6118,7 @@
                 </a:solidFill>
                 <a:latin typeface="Calibri"/>
               </a:rPr>
-              <a:t>40 yrs of reputation -&gt; predictable case flow</a:t>
+              <a:t>Stage 4 → Stage 6 Firm</a:t>
             </a:r>
           </a:p>
         </p:txBody>
@@ -6151,7 +6151,7 @@
                 </a:solidFill>
                 <a:latin typeface="Calibri"/>
               </a:rPr>
-              <a:t>Focus on cases -- not finding them</a:t>
+              <a:t>A firm that generates cases — and runs without you chasing them</a:t>
             </a:r>
           </a:p>
         </p:txBody>
@@ -6418,7 +6418,7 @@
                 </a:solidFill>
                 <a:latin typeface="Calibri"/>
               </a:rPr>
-              <a:t>Turn Google into a client pipeline that runs itself</a:t>
+              <a:t>Turn Google into a PI case pipeline for Cox Pradia</a:t>
             </a:r>
           </a:p>
         </p:txBody>
@@ -6541,7 +6541,7 @@
                 </a:solidFill>
                 <a:latin typeface="Calibri"/>
               </a:rPr>
-              <a:t>Win the top LSA spot above every paid ad</a:t>
+              <a:t>Activate LSA — pay per qualified lead, not per click</a:t>
             </a:r>
           </a:p>
         </p:txBody>
@@ -6664,7 +6664,7 @@
                 </a:solidFill>
                 <a:latin typeface="Calibri"/>
               </a:rPr>
-              <a:t>Fix directory listings to reclaim 3-pack eligibility</a:t>
+              <a:t>Fix 2-address NAP issue — reclaim 3-pack eligibility</a:t>
             </a:r>
           </a:p>
         </p:txBody>
@@ -6787,7 +6787,7 @@
                 </a:solidFill>
                 <a:latin typeface="Calibri"/>
               </a:rPr>
-              <a:t>Build review velocity to outpace Houston competitors</a:t>
+              <a:t>Build suburb pages: Katy, Sugar Land, The Woodlands</a:t>
             </a:r>
           </a:p>
         </p:txBody>
@@ -6910,7 +6910,7 @@
                 </a:solidFill>
                 <a:latin typeface="Calibri"/>
               </a:rPr>
-              <a:t>Add suburb pages for Katy, Sugar Land, Woodlands</a:t>
+              <a:t>Launch review system — close the 24x gap vs. Zehl</a:t>
             </a:r>
           </a:p>
         </p:txBody>
@@ -7177,7 +7177,7 @@
                 </a:solidFill>
                 <a:latin typeface="Calibri"/>
               </a:rPr>
-              <a:t>Add above-fold form to capture leads before they leave</a:t>
+              <a:t>Add above-fold form — capture leads before they scroll</a:t>
             </a:r>
           </a:p>
         </p:txBody>
@@ -7300,7 +7300,7 @@
                 </a:solidFill>
                 <a:latin typeface="Calibri"/>
               </a:rPr>
-              <a:t>Activate Avvo reviews to close the directory trust gap</a:t>
+              <a:t>Digital after-hours capture for late-night PI contacts</a:t>
             </a:r>
           </a:p>
         </p:txBody>
@@ -7423,7 +7423,7 @@
                 </a:solidFill>
                 <a:latin typeface="Calibri"/>
               </a:rPr>
-              <a:t>Set response standards -- first to respond wins cases</a:t>
+              <a:t>Activate Avvo reviews — 0 on a 27-year attorney profile</a:t>
             </a:r>
           </a:p>
         </p:txBody>
@@ -7546,7 +7546,7 @@
                 </a:solidFill>
                 <a:latin typeface="Calibri"/>
               </a:rPr>
-              <a:t>Launch post-case Google review collection system</a:t>
+              <a:t>Spanish-language intake — Houston is 44% Hispanic</a:t>
             </a:r>
           </a:p>
         </p:txBody>
@@ -7669,7 +7669,7 @@
                 </a:solidFill>
                 <a:latin typeface="Calibri"/>
               </a:rPr>
-              <a:t>Track close rate and case value by lead source</a:t>
+              <a:t>Track lead source at intake — know what converts</a:t>
             </a:r>
           </a:p>
         </p:txBody>
@@ -7936,7 +7936,7 @@
                 </a:solidFill>
                 <a:latin typeface="Calibri"/>
               </a:rPr>
-              <a:t>Define KPIs so the team runs without daily oversight</a:t>
+              <a:t>Set monthly case + lead targets with Master's Circle</a:t>
             </a:r>
           </a:p>
         </p:txBody>
@@ -8059,7 +8059,7 @@
                 </a:solidFill>
                 <a:latin typeface="Calibri"/>
               </a:rPr>
-              <a:t>Document intake SLAs for consistent follow-up</a:t>
+              <a:t>Peer accountability with $1M+ PI firm owners</a:t>
             </a:r>
           </a:p>
         </p:txBody>
@@ -8182,7 +8182,7 @@
                 </a:solidFill>
                 <a:latin typeface="Calibri"/>
               </a:rPr>
-              <a:t>Build monthly profit dashboard -- know the margins</a:t>
+              <a:t>Implement case acquisition cost tracking from day one</a:t>
             </a:r>
           </a:p>
         </p:txBody>
@@ -8305,7 +8305,7 @@
                 </a:solidFill>
                 <a:latin typeface="Calibri"/>
               </a:rPr>
-              <a:t>Track cost-per-case and double down on winners</a:t>
+              <a:t>Build a mgmt layer — so partners choose their focus</a:t>
             </a:r>
           </a:p>
         </p:txBody>
@@ -8428,7 +8428,7 @@
                 </a:solidFill>
                 <a:latin typeface="Calibri"/>
               </a:rPr>
-              <a:t>Build a referral engine to convert case wins into new clients</a:t>
+              <a:t>Define revenue goal — engineer profit from the start</a:t>
             </a:r>
           </a:p>
         </p:txBody>
@@ -8530,7 +8530,7 @@
                 </a:solidFill>
                 <a:latin typeface="Calibri"/>
               </a:rPr>
-              <a:t>CONFIDENTIAL  -  Prepared by Nick Holderman | SMB Team</a:t>
+              <a:t>CONFIDENTIAL  ·  Prepared by Nick Holderman | SMB Team</a:t>
             </a:r>
           </a:p>
         </p:txBody>
@@ -8659,7 +8659,7 @@
                 </a:solidFill>
                 <a:latin typeface="Calibri"/>
               </a:rPr>
-              <a:t>LAW FIRM GROWTH AUDIT  -  THE COX PRADIA LAW FIRM</a:t>
+              <a:t>LAW FIRM GROWTH AUDIT  ·  THE COX PRADIA LAW FIRM</a:t>
             </a:r>
           </a:p>
         </p:txBody>
@@ -8815,7 +8815,7 @@
                 </a:solidFill>
                 <a:latin typeface="Calibri"/>
               </a:rPr>
-              <a:t>FULL SERVICE MARKETING -- GROWTH</a:t>
+              <a:t>FULL SERVICE MARKETING — GROWTH</a:t>
             </a:r>
           </a:p>
         </p:txBody>
@@ -8848,7 +8848,7 @@
                 </a:solidFill>
                 <a:latin typeface="Calibri"/>
               </a:rPr>
-              <a:t>$8,997</a:t>
+              <a:t>$7,397</a:t>
             </a:r>
           </a:p>
         </p:txBody>
@@ -8914,7 +8914,7 @@
                 </a:solidFill>
                 <a:latin typeface="Calibri"/>
               </a:rPr>
-              <a:t/>
+              <a:t>$8,997/mo</a:t>
             </a:r>
           </a:p>
         </p:txBody>
@@ -8992,7 +8992,7 @@
                 </a:solidFill>
                 <a:latin typeface="Calibri"/>
               </a:rPr>
-              <a:t>Google Ads, LSA, Meta Ads, SEO, Website Optimization</a:t>
+              <a:t>Google Ads · LSA · Meta · Full SEO · Website Optimization</a:t>
             </a:r>
           </a:p>
         </p:txBody>
@@ -9057,7 +9057,7 @@
             <a:avLst/>
           </a:prstGeom>
           <a:solidFill>
-            <a:srgbClr val="F5C400"/>
+            <a:srgbClr val="6D28D9"/>
           </a:solidFill>
           <a:ln>
             <a:solidFill>
@@ -9111,11 +9111,11 @@
             <a:r>
               <a:rPr sz="800" b="1" i="0">
                 <a:solidFill>
-                  <a:srgbClr val="F5C400"/>
-                </a:solidFill>
-                <a:latin typeface="Calibri"/>
-              </a:rPr>
-              <a:t>ONE-TIME SETUP FEE</a:t>
+                  <a:srgbClr val="6D28D9"/>
+                </a:solidFill>
+                <a:latin typeface="Calibri"/>
+              </a:rPr>
+              <a:t>MASTER'S CIRCLE</a:t>
             </a:r>
           </a:p>
         </p:txBody>
@@ -9128,7 +9128,7 @@
         </p:nvSpPr>
         <p:spPr>
           <a:xfrm>
-            <a:off x="475488" y="2395728"/>
+            <a:off x="475488" y="2414015"/>
             <a:ext cx="1828800" cy="438912"/>
           </a:xfrm>
           <a:prstGeom prst="rect">
@@ -9148,7 +9148,7 @@
                 </a:solidFill>
                 <a:latin typeface="Calibri"/>
               </a:rPr>
-              <a:t>$2,200</a:t>
+              <a:t>$4,600</a:t>
             </a:r>
           </a:p>
         </p:txBody>
@@ -9161,8 +9161,8 @@
         </p:nvSpPr>
         <p:spPr>
           <a:xfrm>
-            <a:off x="1865376" y="2505456"/>
-            <a:ext cx="731520" cy="256032"/>
+            <a:off x="1865376" y="2523744"/>
+            <a:ext cx="420624" cy="256032"/>
           </a:xfrm>
           <a:prstGeom prst="rect">
             <a:avLst/>
@@ -9181,7 +9181,7 @@
                 </a:solidFill>
                 <a:latin typeface="Calibri"/>
               </a:rPr>
-              <a:t>one-time</a:t>
+              <a:t>/mo</a:t>
             </a:r>
           </a:p>
         </p:txBody>
@@ -9194,8 +9194,8 @@
         </p:nvSpPr>
         <p:spPr>
           <a:xfrm>
-            <a:off x="475488" y="2926080"/>
-            <a:ext cx="3803904" cy="201168"/>
+            <a:off x="2322576" y="2542032"/>
+            <a:ext cx="914400" cy="237744"/>
           </a:xfrm>
           <a:prstGeom prst="rect">
             <a:avLst/>
@@ -9208,13 +9208,13 @@
           <a:p>
             <a:pPr algn="l"/>
             <a:r>
-              <a:rPr sz="800" b="0" i="0">
-                <a:solidFill>
-                  <a:srgbClr val="64748B"/>
-                </a:solidFill>
-                <a:latin typeface="Calibri"/>
-              </a:rPr>
-              <a:t>Campaign build, tracking setup, and account configuration</a:t>
+              <a:rPr sz="1100" b="0" i="0">
+                <a:solidFill>
+                  <a:srgbClr val="334155"/>
+                </a:solidFill>
+                <a:latin typeface="Calibri"/>
+              </a:rPr>
+              <a:t>$4,997/mo</a:t>
             </a:r>
           </a:p>
         </p:txBody>
@@ -9227,7 +9227,229 @@
         </p:nvSpPr>
         <p:spPr>
           <a:xfrm>
+            <a:off x="2322576" y="2642615"/>
+            <a:ext cx="804672" cy="9144"/>
+          </a:xfrm>
+          <a:prstGeom prst="rect">
+            <a:avLst/>
+          </a:prstGeom>
+          <a:solidFill>
+            <a:srgbClr val="334155"/>
+          </a:solidFill>
+          <a:ln>
+            <a:solidFill>
+              <a:srgbClr val="FFFFFF"/>
+            </a:solidFill>
+          </a:ln>
+        </p:spPr>
+        <p:style>
+          <a:lnRef idx="1">
+            <a:schemeClr val="accent1"/>
+          </a:lnRef>
+          <a:fillRef idx="3">
+            <a:schemeClr val="accent1"/>
+          </a:fillRef>
+          <a:effectRef idx="2">
+            <a:schemeClr val="accent1"/>
+          </a:effectRef>
+          <a:fontRef idx="minor">
+            <a:schemeClr val="lt1"/>
+          </a:fontRef>
+        </p:style>
+        <p:txBody>
+          <a:bodyPr rtlCol="0" anchor="ctr"/>
+          <a:lstStyle/>
+          <a:p>
+            <a:pPr algn="ctr"/>
+          </a:p>
+        </p:txBody>
+      </p:sp>
+      <p:sp>
+        <p:nvSpPr>
+          <p:cNvPr id="20" name="TextBox 19"/>
+          <p:cNvSpPr txBox="1"/>
+          <p:nvPr/>
+        </p:nvSpPr>
+        <p:spPr>
+          <a:xfrm>
+            <a:off x="475488" y="2907791"/>
+            <a:ext cx="3803904" cy="201168"/>
+          </a:xfrm>
+          <a:prstGeom prst="rect">
+            <a:avLst/>
+          </a:prstGeom>
+          <a:noFill/>
+        </p:spPr>
+        <p:txBody>
+          <a:bodyPr wrap="square"/>
+          <a:lstStyle/>
+          <a:p>
+            <a:pPr algn="l"/>
+            <a:r>
+              <a:rPr sz="800" b="0" i="0">
+                <a:solidFill>
+                  <a:srgbClr val="64748B"/>
+                </a:solidFill>
+                <a:latin typeface="Calibri"/>
+              </a:rPr>
+              <a:t>Weekly coaching · PI masterminds · Quarterly workshops</a:t>
+            </a:r>
+          </a:p>
+        </p:txBody>
+      </p:sp>
+      <p:sp>
+        <p:nvSpPr>
+          <p:cNvPr id="21" name="Rectangle 20"/>
+          <p:cNvSpPr/>
+          <p:nvPr/>
+        </p:nvSpPr>
+        <p:spPr>
+          <a:xfrm>
             <a:off x="201168" y="3255264"/>
+            <a:ext cx="4133087" cy="658368"/>
+          </a:xfrm>
+          <a:prstGeom prst="rect">
+            <a:avLst/>
+          </a:prstGeom>
+          <a:solidFill>
+            <a:srgbClr val="0D1F3C"/>
+          </a:solidFill>
+          <a:ln>
+            <a:solidFill>
+              <a:srgbClr val="FFFFFF"/>
+            </a:solidFill>
+          </a:ln>
+        </p:spPr>
+        <p:style>
+          <a:lnRef idx="1">
+            <a:schemeClr val="accent1"/>
+          </a:lnRef>
+          <a:fillRef idx="3">
+            <a:schemeClr val="accent1"/>
+          </a:fillRef>
+          <a:effectRef idx="2">
+            <a:schemeClr val="accent1"/>
+          </a:effectRef>
+          <a:fontRef idx="minor">
+            <a:schemeClr val="lt1"/>
+          </a:fontRef>
+        </p:style>
+        <p:txBody>
+          <a:bodyPr rtlCol="0" anchor="ctr"/>
+          <a:lstStyle/>
+          <a:p>
+            <a:pPr algn="ctr"/>
+          </a:p>
+        </p:txBody>
+      </p:sp>
+      <p:sp>
+        <p:nvSpPr>
+          <p:cNvPr id="22" name="TextBox 21"/>
+          <p:cNvSpPr txBox="1"/>
+          <p:nvPr/>
+        </p:nvSpPr>
+        <p:spPr>
+          <a:xfrm>
+            <a:off x="384048" y="3291840"/>
+            <a:ext cx="1645920" cy="237744"/>
+          </a:xfrm>
+          <a:prstGeom prst="rect">
+            <a:avLst/>
+          </a:prstGeom>
+          <a:noFill/>
+        </p:spPr>
+        <p:txBody>
+          <a:bodyPr wrap="square"/>
+          <a:lstStyle/>
+          <a:p>
+            <a:pPr algn="l"/>
+            <a:r>
+              <a:rPr sz="800" b="1" i="0">
+                <a:solidFill>
+                  <a:srgbClr val="7CA0C0"/>
+                </a:solidFill>
+                <a:latin typeface="Calibri"/>
+              </a:rPr>
+              <a:t>BUNDLE TOTAL</a:t>
+            </a:r>
+          </a:p>
+        </p:txBody>
+      </p:sp>
+      <p:sp>
+        <p:nvSpPr>
+          <p:cNvPr id="23" name="TextBox 22"/>
+          <p:cNvSpPr txBox="1"/>
+          <p:nvPr/>
+        </p:nvSpPr>
+        <p:spPr>
+          <a:xfrm>
+            <a:off x="384048" y="3493008"/>
+            <a:ext cx="2194560" cy="347472"/>
+          </a:xfrm>
+          <a:prstGeom prst="rect">
+            <a:avLst/>
+          </a:prstGeom>
+          <a:noFill/>
+        </p:spPr>
+        <p:txBody>
+          <a:bodyPr wrap="square"/>
+          <a:lstStyle/>
+          <a:p>
+            <a:pPr algn="l"/>
+            <a:r>
+              <a:rPr sz="2200" b="1" i="0">
+                <a:solidFill>
+                  <a:srgbClr val="F5C400"/>
+                </a:solidFill>
+                <a:latin typeface="Calibri"/>
+              </a:rPr>
+              <a:t>$11,997 / mo</a:t>
+            </a:r>
+          </a:p>
+        </p:txBody>
+      </p:sp>
+      <p:sp>
+        <p:nvSpPr>
+          <p:cNvPr id="24" name="TextBox 23"/>
+          <p:cNvSpPr txBox="1"/>
+          <p:nvPr/>
+        </p:nvSpPr>
+        <p:spPr>
+          <a:xfrm>
+            <a:off x="2670048" y="3493008"/>
+            <a:ext cx="1737360" cy="347472"/>
+          </a:xfrm>
+          <a:prstGeom prst="rect">
+            <a:avLst/>
+          </a:prstGeom>
+          <a:noFill/>
+        </p:spPr>
+        <p:txBody>
+          <a:bodyPr wrap="square"/>
+          <a:lstStyle/>
+          <a:p>
+            <a:pPr algn="l"/>
+            <a:r>
+              <a:rPr sz="800" b="0" i="0">
+                <a:solidFill>
+                  <a:srgbClr val="7CA0C0"/>
+                </a:solidFill>
+                <a:latin typeface="Calibri"/>
+              </a:rPr>
+              <a:t>Save $1,997/mo by bundling</a:t>
+            </a:r>
+          </a:p>
+        </p:txBody>
+      </p:sp>
+      <p:sp>
+        <p:nvSpPr>
+          <p:cNvPr id="25" name="Rectangle 24"/>
+          <p:cNvSpPr/>
+          <p:nvPr/>
+        </p:nvSpPr>
+        <p:spPr>
+          <a:xfrm>
+            <a:off x="201168" y="3968496"/>
             <a:ext cx="4133087" cy="402336"/>
           </a:xfrm>
           <a:prstGeom prst="rect">
@@ -9266,13 +9488,13 @@
       </p:sp>
       <p:sp>
         <p:nvSpPr>
-          <p:cNvPr id="20" name="TextBox 19"/>
-          <p:cNvSpPr txBox="1"/>
-          <p:nvPr/>
-        </p:nvSpPr>
-        <p:spPr>
-          <a:xfrm>
-            <a:off x="329184" y="3282696"/>
+          <p:cNvPr id="26" name="TextBox 25"/>
+          <p:cNvSpPr txBox="1"/>
+          <p:nvPr/>
+        </p:nvSpPr>
+        <p:spPr>
+          <a:xfrm>
+            <a:off x="329184" y="3995928"/>
             <a:ext cx="3931920" cy="347472"/>
           </a:xfrm>
           <a:prstGeom prst="rect">
@@ -9292,14 +9514,14 @@
                 </a:solidFill>
                 <a:latin typeface="Calibri"/>
               </a:rPr>
-              <a:t>+ Recommended ad spend: $19,500-$50,000/mo paid directly to Google/Meta</a:t>
-            </a:r>
-          </a:p>
-        </p:txBody>
-      </p:sp>
-      <p:sp>
-        <p:nvSpPr>
-          <p:cNvPr id="21" name="Rectangle 20"/>
+              <a:t>+ Recommended ad spend: $19,500–$50,000/mo paid directly to Google/Meta/LSA</a:t>
+            </a:r>
+          </a:p>
+        </p:txBody>
+      </p:sp>
+      <p:sp>
+        <p:nvSpPr>
+          <p:cNvPr id="27" name="Rectangle 26"/>
           <p:cNvSpPr/>
           <p:nvPr/>
         </p:nvSpPr>
@@ -9344,7 +9566,7 @@
       </p:sp>
       <p:sp>
         <p:nvSpPr>
-          <p:cNvPr id="22" name="TextBox 21"/>
+          <p:cNvPr id="28" name="TextBox 27"/>
           <p:cNvSpPr txBox="1"/>
           <p:nvPr/>
         </p:nvSpPr>
@@ -9377,7 +9599,7 @@
       </p:sp>
       <p:sp>
         <p:nvSpPr>
-          <p:cNvPr id="23" name="TextBox 22"/>
+          <p:cNvPr id="29" name="TextBox 28"/>
           <p:cNvSpPr txBox="1"/>
           <p:nvPr/>
         </p:nvSpPr>
@@ -9410,7 +9632,7 @@
       </p:sp>
       <p:sp>
         <p:nvSpPr>
-          <p:cNvPr id="24" name="TextBox 23"/>
+          <p:cNvPr id="30" name="TextBox 29"/>
           <p:cNvSpPr txBox="1"/>
           <p:nvPr/>
         </p:nvSpPr>
@@ -9443,7 +9665,7 @@
       </p:sp>
       <p:sp>
         <p:nvSpPr>
-          <p:cNvPr id="25" name="Rectangle 24"/>
+          <p:cNvPr id="31" name="Rectangle 30"/>
           <p:cNvSpPr/>
           <p:nvPr/>
         </p:nvSpPr>
@@ -9488,7 +9710,7 @@
       </p:sp>
       <p:sp>
         <p:nvSpPr>
-          <p:cNvPr id="26" name="TextBox 25"/>
+          <p:cNvPr id="32" name="TextBox 31"/>
           <p:cNvSpPr txBox="1"/>
           <p:nvPr/>
         </p:nvSpPr>
@@ -9521,7 +9743,7 @@
       </p:sp>
       <p:sp>
         <p:nvSpPr>
-          <p:cNvPr id="27" name="TextBox 26"/>
+          <p:cNvPr id="33" name="TextBox 32"/>
           <p:cNvSpPr txBox="1"/>
           <p:nvPr/>
         </p:nvSpPr>
@@ -9547,14 +9769,14 @@
                 </a:solidFill>
                 <a:latin typeface="Calibri"/>
               </a:rPr>
-              <a:t>$300,000 revenue  15x ROAS</a:t>
-            </a:r>
-          </a:p>
-        </p:txBody>
-      </p:sp>
-      <p:sp>
-        <p:nvSpPr>
-          <p:cNvPr id="28" name="TextBox 27"/>
+              <a:t>$300,000 revenue · 15× ROAS</a:t>
+            </a:r>
+          </a:p>
+        </p:txBody>
+      </p:sp>
+      <p:sp>
+        <p:nvSpPr>
+          <p:cNvPr id="34" name="TextBox 33"/>
           <p:cNvSpPr txBox="1"/>
           <p:nvPr/>
         </p:nvSpPr>
@@ -9587,7 +9809,7 @@
       </p:sp>
       <p:sp>
         <p:nvSpPr>
-          <p:cNvPr id="29" name="TextBox 28"/>
+          <p:cNvPr id="35" name="TextBox 34"/>
           <p:cNvSpPr txBox="1"/>
           <p:nvPr/>
         </p:nvSpPr>
@@ -9613,14 +9835,14 @@
                 </a:solidFill>
                 <a:latin typeface="Calibri"/>
               </a:rPr>
-              <a:t>$850,000 revenue  17x ROAS</a:t>
-            </a:r>
-          </a:p>
-        </p:txBody>
-      </p:sp>
-      <p:sp>
-        <p:nvSpPr>
-          <p:cNvPr id="30" name="TextBox 29"/>
+              <a:t>$850,000 revenue · 17× ROAS</a:t>
+            </a:r>
+          </a:p>
+        </p:txBody>
+      </p:sp>
+      <p:sp>
+        <p:nvSpPr>
+          <p:cNvPr id="36" name="TextBox 35"/>
           <p:cNvSpPr txBox="1"/>
           <p:nvPr/>
         </p:nvSpPr>
@@ -9653,7 +9875,7 @@
       </p:sp>
       <p:sp>
         <p:nvSpPr>
-          <p:cNvPr id="31" name="Rectangle 30"/>
+          <p:cNvPr id="37" name="Rectangle 36"/>
           <p:cNvSpPr/>
           <p:nvPr/>
         </p:nvSpPr>
@@ -9698,7 +9920,7 @@
       </p:sp>
       <p:sp>
         <p:nvSpPr>
-          <p:cNvPr id="32" name="TextBox 31"/>
+          <p:cNvPr id="38" name="TextBox 37"/>
           <p:cNvSpPr txBox="1"/>
           <p:nvPr/>
         </p:nvSpPr>
@@ -9731,7 +9953,7 @@
       </p:sp>
       <p:sp>
         <p:nvSpPr>
-          <p:cNvPr id="33" name="TextBox 32"/>
+          <p:cNvPr id="39" name="TextBox 38"/>
           <p:cNvSpPr txBox="1"/>
           <p:nvPr/>
         </p:nvSpPr>
@@ -9757,14 +9979,14 @@
                 </a:solidFill>
                 <a:latin typeface="Calibri"/>
               </a:rPr>
-              <a:t>Google Ads &amp; LSA campaigns launched</a:t>
-            </a:r>
-          </a:p>
-        </p:txBody>
-      </p:sp>
-      <p:sp>
-        <p:nvSpPr>
-          <p:cNvPr id="34" name="Rectangle 33"/>
+              <a:t>Google Ads + LSA campaigns launched and live</a:t>
+            </a:r>
+          </a:p>
+        </p:txBody>
+      </p:sp>
+      <p:sp>
+        <p:nvSpPr>
+          <p:cNvPr id="40" name="Rectangle 39"/>
           <p:cNvSpPr/>
           <p:nvPr/>
         </p:nvSpPr>
@@ -9809,7 +10031,7 @@
       </p:sp>
       <p:sp>
         <p:nvSpPr>
-          <p:cNvPr id="35" name="TextBox 34"/>
+          <p:cNvPr id="41" name="TextBox 40"/>
           <p:cNvSpPr txBox="1"/>
           <p:nvPr/>
         </p:nvSpPr>
@@ -9842,7 +10064,7 @@
       </p:sp>
       <p:sp>
         <p:nvSpPr>
-          <p:cNvPr id="36" name="TextBox 35"/>
+          <p:cNvPr id="42" name="TextBox 41"/>
           <p:cNvSpPr txBox="1"/>
           <p:nvPr/>
         </p:nvSpPr>
@@ -9868,14 +10090,14 @@
                 </a:solidFill>
                 <a:latin typeface="Calibri"/>
               </a:rPr>
-              <a:t>NAP corrections across all directories</a:t>
-            </a:r>
-          </a:p>
-        </p:txBody>
-      </p:sp>
-      <p:sp>
-        <p:nvSpPr>
-          <p:cNvPr id="37" name="Rectangle 36"/>
+              <a:t>NAP corrections submitted to all directories</a:t>
+            </a:r>
+          </a:p>
+        </p:txBody>
+      </p:sp>
+      <p:sp>
+        <p:nvSpPr>
+          <p:cNvPr id="43" name="Rectangle 42"/>
           <p:cNvSpPr/>
           <p:nvPr/>
         </p:nvSpPr>
@@ -9920,7 +10142,7 @@
       </p:sp>
       <p:sp>
         <p:nvSpPr>
-          <p:cNvPr id="38" name="TextBox 37"/>
+          <p:cNvPr id="44" name="TextBox 43"/>
           <p:cNvSpPr txBox="1"/>
           <p:nvPr/>
         </p:nvSpPr>
@@ -9953,7 +10175,7 @@
       </p:sp>
       <p:sp>
         <p:nvSpPr>
-          <p:cNvPr id="39" name="TextBox 38"/>
+          <p:cNvPr id="45" name="TextBox 44"/>
           <p:cNvSpPr txBox="1"/>
           <p:nvPr/>
         </p:nvSpPr>
@@ -9979,14 +10201,14 @@
                 </a:solidFill>
                 <a:latin typeface="Calibri"/>
               </a:rPr>
-              <a:t>Above-fold form + Katy/Sugar Land pages live</a:t>
-            </a:r>
-          </a:p>
-        </p:txBody>
-      </p:sp>
-      <p:sp>
-        <p:nvSpPr>
-          <p:cNvPr id="40" name="Rectangle 39"/>
+              <a:t>Above-fold form + suburb landing pages live</a:t>
+            </a:r>
+          </a:p>
+        </p:txBody>
+      </p:sp>
+      <p:sp>
+        <p:nvSpPr>
+          <p:cNvPr id="46" name="Rectangle 45"/>
           <p:cNvSpPr/>
           <p:nvPr/>
         </p:nvSpPr>
@@ -10031,7 +10253,7 @@
       </p:sp>
       <p:sp>
         <p:nvSpPr>
-          <p:cNvPr id="41" name="TextBox 40"/>
+          <p:cNvPr id="47" name="TextBox 46"/>
           <p:cNvSpPr txBox="1"/>
           <p:nvPr/>
         </p:nvSpPr>
@@ -10064,7 +10286,7 @@
       </p:sp>
       <p:sp>
         <p:nvSpPr>
-          <p:cNvPr id="42" name="TextBox 41"/>
+          <p:cNvPr id="48" name="TextBox 47"/>
           <p:cNvSpPr txBox="1"/>
           <p:nvPr/>
         </p:nvSpPr>
@@ -10090,14 +10312,14 @@
                 </a:solidFill>
                 <a:latin typeface="Calibri"/>
               </a:rPr>
-              <a:t>Google review request system activated</a:t>
-            </a:r>
-          </a:p>
-        </p:txBody>
-      </p:sp>
-      <p:sp>
-        <p:nvSpPr>
-          <p:cNvPr id="43" name="Rectangle 42"/>
+              <a:t>Automated review request system activated</a:t>
+            </a:r>
+          </a:p>
+        </p:txBody>
+      </p:sp>
+      <p:sp>
+        <p:nvSpPr>
+          <p:cNvPr id="49" name="Rectangle 48"/>
           <p:cNvSpPr/>
           <p:nvPr/>
         </p:nvSpPr>
@@ -10142,7 +10364,7 @@
       </p:sp>
       <p:sp>
         <p:nvSpPr>
-          <p:cNvPr id="44" name="TextBox 43"/>
+          <p:cNvPr id="50" name="TextBox 49"/>
           <p:cNvSpPr txBox="1"/>
           <p:nvPr/>
         </p:nvSpPr>
@@ -10175,7 +10397,7 @@
       </p:sp>
       <p:sp>
         <p:nvSpPr>
-          <p:cNvPr id="45" name="TextBox 44"/>
+          <p:cNvPr id="51" name="TextBox 50"/>
           <p:cNvSpPr txBox="1"/>
           <p:nvPr/>
         </p:nvSpPr>
@@ -10201,14 +10423,14 @@
                 </a:solidFill>
                 <a:latin typeface="Calibri"/>
               </a:rPr>
-              <a:t>ROI dashboard live + review velocity targets set</a:t>
-            </a:r>
-          </a:p>
-        </p:txBody>
-      </p:sp>
-      <p:sp>
-        <p:nvSpPr>
-          <p:cNvPr id="46" name="Rectangle 45"/>
+              <a:t>Coaching kickoff — revenue goal + targets set</a:t>
+            </a:r>
+          </a:p>
+        </p:txBody>
+      </p:sp>
+      <p:sp>
+        <p:nvSpPr>
+          <p:cNvPr id="52" name="Rectangle 51"/>
           <p:cNvSpPr/>
           <p:nvPr/>
         </p:nvSpPr>
@@ -10253,7 +10475,7 @@
       </p:sp>
       <p:sp>
         <p:nvSpPr>
-          <p:cNvPr id="47" name="TextBox 46"/>
+          <p:cNvPr id="53" name="TextBox 52"/>
           <p:cNvSpPr txBox="1"/>
           <p:nvPr/>
         </p:nvSpPr>
@@ -10279,14 +10501,14 @@
                 </a:solidFill>
                 <a:latin typeface="Calibri"/>
               </a:rPr>
-              <a:t>"The cases are in this market. The team is already in place. The only thing missing is the system that turns this firm's reputation into revenue -- and that is exactly what we build."</a:t>
-            </a:r>
-          </a:p>
-        </p:txBody>
-      </p:sp>
-      <p:sp>
-        <p:nvSpPr>
-          <p:cNvPr id="48" name="Rectangle 47"/>
+              <a:t>“For 40 years, you’ve fought for people who couldn’t fight for themselves. Now it’s time for your firm to fight for you — generating the cases, the revenue, and the freedom your work has earned.”</a:t>
+            </a:r>
+          </a:p>
+        </p:txBody>
+      </p:sp>
+      <p:sp>
+        <p:nvSpPr>
+          <p:cNvPr id="54" name="Rectangle 53"/>
           <p:cNvSpPr/>
           <p:nvPr/>
         </p:nvSpPr>
@@ -10331,7 +10553,7 @@
       </p:sp>
       <p:pic>
         <p:nvPicPr>
-          <p:cNvPr id="49" name="Picture 48" descr="smb_team_logo.png"/>
+          <p:cNvPr id="55" name="Picture 54" descr="smb_team_logo.png"/>
           <p:cNvPicPr>
             <a:picLocks noChangeAspect="1"/>
           </p:cNvPicPr>
@@ -10355,7 +10577,7 @@
       </p:pic>
       <p:sp>
         <p:nvSpPr>
-          <p:cNvPr id="50" name="TextBox 49"/>
+          <p:cNvPr id="56" name="TextBox 55"/>
           <p:cNvSpPr txBox="1"/>
           <p:nvPr/>
         </p:nvSpPr>
@@ -10381,14 +10603,14 @@
                 </a:solidFill>
                 <a:latin typeface="Calibri"/>
               </a:rPr>
-              <a:t>CONFIDENTIAL  -  Prepared by Nick Holderman | SMB Team</a:t>
-            </a:r>
-          </a:p>
-        </p:txBody>
-      </p:sp>
-      <p:sp>
-        <p:nvSpPr>
-          <p:cNvPr id="51" name="TextBox 50"/>
+              <a:t>CONFIDENTIAL  ·  Prepared by Nick Holderman | SMB Team</a:t>
+            </a:r>
+          </a:p>
+        </p:txBody>
+      </p:sp>
+      <p:sp>
+        <p:nvSpPr>
+          <p:cNvPr id="57" name="TextBox 56"/>
           <p:cNvSpPr txBox="1"/>
           <p:nvPr/>
         </p:nvSpPr>

</xml_diff>